<commit_message>
modified:   chapter04/ASE_4_Pair_Collaboration.pptx 	modified:   chapter07/ASE_7_SE_in_Industry.pptx 	modified:   chapter08/ASE_8_Requirement.pptx 	modified:   chapter09/ASE_9_program_manager.pptx 	modified:   chapter10/ASE_10_Scenario Based Engineering.pptx 	modified:   chapter11/ASE_11_Design_Implementation.pptx 	modified:   chapter12/ASE_12_User_eXperience.pptx
</commit_message>
<xml_diff>
--- a/chapter10/ASE_10_Scenario Based Engineering.pptx
+++ b/chapter10/ASE_10_Scenario Based Engineering.pptx
@@ -2,62 +2,62 @@
 <file path=ppt/presentation.xml><?xml version="1.0" encoding="utf-8"?>
 <p:presentation xmlns:a="http://schemas.openxmlformats.org/drawingml/2006/main" xmlns:r="http://schemas.openxmlformats.org/officeDocument/2006/relationships" xmlns:p="http://schemas.openxmlformats.org/presentationml/2006/main">
   <p:sldMasterIdLst>
-    <p:sldMasterId id="2147483648" r:id="rId1"/>
+    <p:sldMasterId id="2147483648" r:id="rId4"/>
   </p:sldMasterIdLst>
   <p:notesMasterIdLst>
-    <p:notesMasterId r:id="rId6"/>
+    <p:notesMasterId r:id="rId55"/>
   </p:notesMasterIdLst>
   <p:sldIdLst>
-    <p:sldId id="256" r:id="rId3"/>
-    <p:sldId id="365" r:id="rId4"/>
-    <p:sldId id="259" r:id="rId5"/>
-    <p:sldId id="260" r:id="rId7"/>
-    <p:sldId id="261" r:id="rId8"/>
-    <p:sldId id="275" r:id="rId9"/>
-    <p:sldId id="276" r:id="rId10"/>
-    <p:sldId id="277" r:id="rId11"/>
-    <p:sldId id="280" r:id="rId12"/>
-    <p:sldId id="278" r:id="rId13"/>
-    <p:sldId id="279" r:id="rId14"/>
-    <p:sldId id="274" r:id="rId15"/>
-    <p:sldId id="263" r:id="rId16"/>
-    <p:sldId id="366" r:id="rId17"/>
-    <p:sldId id="367" r:id="rId18"/>
-    <p:sldId id="368" r:id="rId19"/>
-    <p:sldId id="369" r:id="rId20"/>
-    <p:sldId id="370" r:id="rId21"/>
-    <p:sldId id="371" r:id="rId22"/>
-    <p:sldId id="373" r:id="rId23"/>
-    <p:sldId id="297" r:id="rId24"/>
-    <p:sldId id="301" r:id="rId25"/>
-    <p:sldId id="404" r:id="rId26"/>
-    <p:sldId id="390" r:id="rId27"/>
-    <p:sldId id="268" r:id="rId28"/>
-    <p:sldId id="269" r:id="rId29"/>
-    <p:sldId id="270" r:id="rId30"/>
-    <p:sldId id="271" r:id="rId31"/>
-    <p:sldId id="272" r:id="rId32"/>
-    <p:sldId id="273" r:id="rId33"/>
-    <p:sldId id="391" r:id="rId34"/>
-    <p:sldId id="281" r:id="rId35"/>
-    <p:sldId id="392" r:id="rId36"/>
-    <p:sldId id="267" r:id="rId37"/>
-    <p:sldId id="393" r:id="rId38"/>
-    <p:sldId id="394" r:id="rId39"/>
-    <p:sldId id="395" r:id="rId40"/>
-    <p:sldId id="396" r:id="rId41"/>
-    <p:sldId id="397" r:id="rId42"/>
-    <p:sldId id="398" r:id="rId43"/>
-    <p:sldId id="399" r:id="rId44"/>
-    <p:sldId id="400" r:id="rId45"/>
-    <p:sldId id="401" r:id="rId46"/>
-    <p:sldId id="402" r:id="rId47"/>
-    <p:sldId id="322" r:id="rId48"/>
-    <p:sldId id="323" r:id="rId49"/>
-    <p:sldId id="324" r:id="rId50"/>
-    <p:sldId id="325" r:id="rId51"/>
-    <p:sldId id="326" r:id="rId52"/>
-    <p:sldId id="403" r:id="rId53"/>
+    <p:sldId id="256" r:id="rId5"/>
+    <p:sldId id="365" r:id="rId6"/>
+    <p:sldId id="259" r:id="rId7"/>
+    <p:sldId id="260" r:id="rId8"/>
+    <p:sldId id="261" r:id="rId9"/>
+    <p:sldId id="275" r:id="rId10"/>
+    <p:sldId id="276" r:id="rId11"/>
+    <p:sldId id="277" r:id="rId12"/>
+    <p:sldId id="280" r:id="rId13"/>
+    <p:sldId id="278" r:id="rId14"/>
+    <p:sldId id="279" r:id="rId15"/>
+    <p:sldId id="274" r:id="rId16"/>
+    <p:sldId id="263" r:id="rId17"/>
+    <p:sldId id="366" r:id="rId18"/>
+    <p:sldId id="367" r:id="rId19"/>
+    <p:sldId id="368" r:id="rId20"/>
+    <p:sldId id="369" r:id="rId21"/>
+    <p:sldId id="370" r:id="rId22"/>
+    <p:sldId id="371" r:id="rId23"/>
+    <p:sldId id="373" r:id="rId24"/>
+    <p:sldId id="297" r:id="rId25"/>
+    <p:sldId id="301" r:id="rId26"/>
+    <p:sldId id="404" r:id="rId27"/>
+    <p:sldId id="390" r:id="rId28"/>
+    <p:sldId id="268" r:id="rId29"/>
+    <p:sldId id="269" r:id="rId30"/>
+    <p:sldId id="270" r:id="rId31"/>
+    <p:sldId id="271" r:id="rId32"/>
+    <p:sldId id="272" r:id="rId33"/>
+    <p:sldId id="273" r:id="rId34"/>
+    <p:sldId id="391" r:id="rId35"/>
+    <p:sldId id="281" r:id="rId36"/>
+    <p:sldId id="392" r:id="rId37"/>
+    <p:sldId id="267" r:id="rId38"/>
+    <p:sldId id="393" r:id="rId39"/>
+    <p:sldId id="394" r:id="rId40"/>
+    <p:sldId id="395" r:id="rId41"/>
+    <p:sldId id="396" r:id="rId42"/>
+    <p:sldId id="397" r:id="rId43"/>
+    <p:sldId id="398" r:id="rId44"/>
+    <p:sldId id="399" r:id="rId45"/>
+    <p:sldId id="400" r:id="rId46"/>
+    <p:sldId id="401" r:id="rId47"/>
+    <p:sldId id="402" r:id="rId48"/>
+    <p:sldId id="322" r:id="rId49"/>
+    <p:sldId id="323" r:id="rId50"/>
+    <p:sldId id="324" r:id="rId51"/>
+    <p:sldId id="325" r:id="rId52"/>
+    <p:sldId id="326" r:id="rId53"/>
+    <p:sldId id="403" r:id="rId54"/>
   </p:sldIdLst>
   <p:sldSz cx="12192000" cy="6858000"/>
   <p:notesSz cx="6858000" cy="9144000"/>
@@ -176,7 +176,7 @@
 </file>
 
 <file path=ppt/diagrams/colors1.xml><?xml version="1.0" encoding="utf-8"?>
-<dgm:colorsDef xmlns:dgm="http://schemas.openxmlformats.org/drawingml/2006/diagram" xmlns:a="http://schemas.openxmlformats.org/drawingml/2006/main" uniqueId="urn:microsoft.com/office/officeart/2005/8/colors/accent6_2">
+<dgm:colorsDef xmlns:dgm="http://schemas.openxmlformats.org/drawingml/2006/diagram" xmlns:a="http://schemas.openxmlformats.org/drawingml/2006/main" uniqueId="urn:microsoft.com/office/officeart/2005/8/colors/accent6_2#1">
   <dgm:title val=""/>
   <dgm:desc val=""/>
   <dgm:catLst>
@@ -926,7 +926,7 @@
 <dgm:dataModel xmlns:dgm="http://schemas.openxmlformats.org/drawingml/2006/diagram" xmlns:a="http://schemas.openxmlformats.org/drawingml/2006/main">
   <dgm:ptLst>
     <dgm:pt modelId="{2EA87C6E-B934-4E05-92CE-11838CD1E152}" type="doc">
-      <dgm:prSet loTypeId="urn:microsoft.com/office/officeart/2005/8/layout/list1" loCatId="list" qsTypeId="urn:microsoft.com/office/officeart/2005/8/quickstyle/simple1" qsCatId="simple" csTypeId="urn:microsoft.com/office/officeart/2005/8/colors/accent6_2" csCatId="accent6"/>
+      <dgm:prSet loTypeId="urn:microsoft.com/office/officeart/2005/8/layout/list1#1" loCatId="list" qsTypeId="urn:microsoft.com/office/officeart/2005/8/quickstyle/simple1#9" qsCatId="simple" csTypeId="urn:microsoft.com/office/officeart/2005/8/colors/accent6_2#1" csCatId="accent6"/>
       <dgm:spPr/>
       <dgm:t>
         <a:bodyPr/>
@@ -959,7 +959,7 @@
         </a:p>
       </dgm:t>
     </dgm:pt>
-    <dgm:pt modelId="{8252ECEA-62AB-4828-8DA3-65022CD24637}" cxnId="{99F3FDEE-BDF9-4728-A424-132E418EFC70}" type="parTrans">
+    <dgm:pt modelId="{8252ECEA-62AB-4828-8DA3-65022CD24637}" type="parTrans" cxnId="{99F3FDEE-BDF9-4728-A424-132E418EFC70}">
       <dgm:prSet/>
       <dgm:spPr/>
       <dgm:t>
@@ -970,7 +970,7 @@
         </a:p>
       </dgm:t>
     </dgm:pt>
-    <dgm:pt modelId="{C588BAC4-428C-457F-A3BA-61DCE356B7B0}" cxnId="{99F3FDEE-BDF9-4728-A424-132E418EFC70}" type="sibTrans">
+    <dgm:pt modelId="{C588BAC4-428C-457F-A3BA-61DCE356B7B0}" type="sibTrans" cxnId="{99F3FDEE-BDF9-4728-A424-132E418EFC70}">
       <dgm:prSet/>
       <dgm:spPr/>
       <dgm:t>
@@ -996,7 +996,7 @@
         </a:p>
       </dgm:t>
     </dgm:pt>
-    <dgm:pt modelId="{ED6853BE-FB3B-4B16-9C50-685E1737CCD0}" cxnId="{30A509B7-AD71-4EE6-95EF-7B54AC6B03D9}" type="parTrans">
+    <dgm:pt modelId="{ED6853BE-FB3B-4B16-9C50-685E1737CCD0}" type="parTrans" cxnId="{30A509B7-AD71-4EE6-95EF-7B54AC6B03D9}">
       <dgm:prSet/>
       <dgm:spPr/>
       <dgm:t>
@@ -1007,7 +1007,7 @@
         </a:p>
       </dgm:t>
     </dgm:pt>
-    <dgm:pt modelId="{8516FDED-D365-4C41-AFE8-C357BA041995}" cxnId="{30A509B7-AD71-4EE6-95EF-7B54AC6B03D9}" type="sibTrans">
+    <dgm:pt modelId="{8516FDED-D365-4C41-AFE8-C357BA041995}" type="sibTrans" cxnId="{30A509B7-AD71-4EE6-95EF-7B54AC6B03D9}">
       <dgm:prSet/>
       <dgm:spPr/>
       <dgm:t>
@@ -1049,7 +1049,7 @@
         </a:p>
       </dgm:t>
     </dgm:pt>
-    <dgm:pt modelId="{2C90661F-8AC4-42B4-9E61-26BDD680B877}" cxnId="{43FD1FD6-0FCB-43E6-B95B-FD1B3ABFA0B7}" type="parTrans">
+    <dgm:pt modelId="{2C90661F-8AC4-42B4-9E61-26BDD680B877}" type="parTrans" cxnId="{43FD1FD6-0FCB-43E6-B95B-FD1B3ABFA0B7}">
       <dgm:prSet/>
       <dgm:spPr/>
       <dgm:t>
@@ -1060,7 +1060,7 @@
         </a:p>
       </dgm:t>
     </dgm:pt>
-    <dgm:pt modelId="{54A2DAF0-A5C3-48FA-90B4-86C66B03274F}" cxnId="{43FD1FD6-0FCB-43E6-B95B-FD1B3ABFA0B7}" type="sibTrans">
+    <dgm:pt modelId="{54A2DAF0-A5C3-48FA-90B4-86C66B03274F}" type="sibTrans" cxnId="{43FD1FD6-0FCB-43E6-B95B-FD1B3ABFA0B7}">
       <dgm:prSet/>
       <dgm:spPr/>
       <dgm:t>
@@ -1086,7 +1086,7 @@
         </a:p>
       </dgm:t>
     </dgm:pt>
-    <dgm:pt modelId="{421A0C26-3270-4ADD-8876-5F909ACDE2A7}" cxnId="{018C73CE-6688-4F3F-AE00-C2DB525E87FE}" type="parTrans">
+    <dgm:pt modelId="{421A0C26-3270-4ADD-8876-5F909ACDE2A7}" type="parTrans" cxnId="{018C73CE-6688-4F3F-AE00-C2DB525E87FE}">
       <dgm:prSet/>
       <dgm:spPr/>
       <dgm:t>
@@ -1097,7 +1097,7 @@
         </a:p>
       </dgm:t>
     </dgm:pt>
-    <dgm:pt modelId="{A825E278-D54E-4863-872D-D5CE7C6722C3}" cxnId="{018C73CE-6688-4F3F-AE00-C2DB525E87FE}" type="sibTrans">
+    <dgm:pt modelId="{A825E278-D54E-4863-872D-D5CE7C6722C3}" type="sibTrans" cxnId="{018C73CE-6688-4F3F-AE00-C2DB525E87FE}">
       <dgm:prSet/>
       <dgm:spPr/>
       <dgm:t>
@@ -1131,7 +1131,7 @@
         </a:p>
       </dgm:t>
     </dgm:pt>
-    <dgm:pt modelId="{6D38F0F7-DB66-42F6-920B-595460B4A01F}" cxnId="{E3D6C501-8BEE-4226-9A14-E5D28E293286}" type="parTrans">
+    <dgm:pt modelId="{6D38F0F7-DB66-42F6-920B-595460B4A01F}" type="parTrans" cxnId="{E3D6C501-8BEE-4226-9A14-E5D28E293286}">
       <dgm:prSet/>
       <dgm:spPr/>
       <dgm:t>
@@ -1142,7 +1142,7 @@
         </a:p>
       </dgm:t>
     </dgm:pt>
-    <dgm:pt modelId="{FAE97EA6-FF95-4F7C-925D-90D71F0B6597}" cxnId="{E3D6C501-8BEE-4226-9A14-E5D28E293286}" type="sibTrans">
+    <dgm:pt modelId="{FAE97EA6-FF95-4F7C-925D-90D71F0B6597}" type="sibTrans" cxnId="{E3D6C501-8BEE-4226-9A14-E5D28E293286}">
       <dgm:prSet/>
       <dgm:spPr/>
       <dgm:t>
@@ -1177,7 +1177,7 @@
         </a:p>
       </dgm:t>
     </dgm:pt>
-    <dgm:pt modelId="{CA409A28-5D97-4E34-AE59-1C11AECBAC79}" cxnId="{F3A06BCF-670E-4C94-A6B2-664C718792BC}" type="parTrans">
+    <dgm:pt modelId="{CA409A28-5D97-4E34-AE59-1C11AECBAC79}" type="parTrans" cxnId="{F3A06BCF-670E-4C94-A6B2-664C718792BC}">
       <dgm:prSet/>
       <dgm:spPr/>
       <dgm:t>
@@ -1188,7 +1188,7 @@
         </a:p>
       </dgm:t>
     </dgm:pt>
-    <dgm:pt modelId="{A33F6413-E18A-4071-90F9-4886A3DE896D}" cxnId="{F3A06BCF-670E-4C94-A6B2-664C718792BC}" type="sibTrans">
+    <dgm:pt modelId="{A33F6413-E18A-4071-90F9-4886A3DE896D}" type="sibTrans" cxnId="{F3A06BCF-670E-4C94-A6B2-664C718792BC}">
       <dgm:prSet/>
       <dgm:spPr/>
       <dgm:t>
@@ -1274,149 +1274,140 @@
   </dgm:ptLst>
   <dgm:cxnLst>
     <dgm:cxn modelId="{E3D6C501-8BEE-4226-9A14-E5D28E293286}" srcId="{53DC1395-671D-462A-85F1-9042DBAEE857}" destId="{161DC7CD-2A9C-494E-A3CB-C00629A94A16}" srcOrd="2" destOrd="0" parTransId="{6D38F0F7-DB66-42F6-920B-595460B4A01F}" sibTransId="{FAE97EA6-FF95-4F7C-925D-90D71F0B6597}"/>
-    <dgm:cxn modelId="{9DDC6617-CE58-406A-95DF-E6435657EDBC}" type="presOf" srcId="{53DC1395-671D-462A-85F1-9042DBAEE857}" destId="{EDAF76F7-74CE-4BC5-A6FF-621F2E8A02C1}" srcOrd="0" destOrd="0" presId="urn:microsoft.com/office/officeart/2005/8/layout/list1"/>
-    <dgm:cxn modelId="{1879242B-BE83-4BDE-84A7-73A3E11C8604}" type="presOf" srcId="{17296CB8-9C76-4A49-9F9D-0C80D092B9C7}" destId="{FF55E445-1FDC-4B0D-B09B-B7C23D2D7B99}" srcOrd="0" destOrd="3" presId="urn:microsoft.com/office/officeart/2005/8/layout/list1"/>
-    <dgm:cxn modelId="{2983E65E-D868-4EC6-9698-6967B22681CE}" type="presOf" srcId="{2EA87C6E-B934-4E05-92CE-11838CD1E152}" destId="{4179BA1F-3973-454C-9A78-CB1EF4B8CA74}" srcOrd="0" destOrd="0" presId="urn:microsoft.com/office/officeart/2005/8/layout/list1"/>
-    <dgm:cxn modelId="{46D20542-6C5E-4D03-A6FB-8CE872731BF4}" type="presOf" srcId="{53DC1395-671D-462A-85F1-9042DBAEE857}" destId="{01F17DE6-0642-40F7-998E-E5607FBDEB40}" srcOrd="1" destOrd="0" presId="urn:microsoft.com/office/officeart/2005/8/layout/list1"/>
-    <dgm:cxn modelId="{EA1C8D5A-12A8-4FF0-9902-445B7AEF5CE8}" type="presOf" srcId="{4DBED84C-00DD-467B-9258-D4072A339320}" destId="{94790145-DC59-4338-8EDF-D5A93440A467}" srcOrd="0" destOrd="0" presId="urn:microsoft.com/office/officeart/2005/8/layout/list1"/>
-    <dgm:cxn modelId="{4AF4187F-883D-4128-8EF6-444B06DBD080}" type="presOf" srcId="{70098AD3-5A16-4CD0-995D-EBE6D75C1CBE}" destId="{FF55E445-1FDC-4B0D-B09B-B7C23D2D7B99}" srcOrd="0" destOrd="0" presId="urn:microsoft.com/office/officeart/2005/8/layout/list1"/>
-    <dgm:cxn modelId="{2AE0668F-7182-4E7C-898B-415AFFE8C20C}" type="presOf" srcId="{161DC7CD-2A9C-494E-A3CB-C00629A94A16}" destId="{FF55E445-1FDC-4B0D-B09B-B7C23D2D7B99}" srcOrd="0" destOrd="2" presId="urn:microsoft.com/office/officeart/2005/8/layout/list1"/>
-    <dgm:cxn modelId="{84107492-A23F-4101-AD61-828CD67B32D0}" type="presOf" srcId="{FD6528C4-B993-4C3E-B58A-A589B3936723}" destId="{FF55E445-1FDC-4B0D-B09B-B7C23D2D7B99}" srcOrd="0" destOrd="1" presId="urn:microsoft.com/office/officeart/2005/8/layout/list1"/>
+    <dgm:cxn modelId="{9DDC6617-CE58-406A-95DF-E6435657EDBC}" type="presOf" srcId="{53DC1395-671D-462A-85F1-9042DBAEE857}" destId="{EDAF76F7-74CE-4BC5-A6FF-621F2E8A02C1}" srcOrd="0" destOrd="0" presId="urn:microsoft.com/office/officeart/2005/8/layout/list1#1"/>
+    <dgm:cxn modelId="{1879242B-BE83-4BDE-84A7-73A3E11C8604}" type="presOf" srcId="{17296CB8-9C76-4A49-9F9D-0C80D092B9C7}" destId="{FF55E445-1FDC-4B0D-B09B-B7C23D2D7B99}" srcOrd="0" destOrd="3" presId="urn:microsoft.com/office/officeart/2005/8/layout/list1#1"/>
+    <dgm:cxn modelId="{2983E65E-D868-4EC6-9698-6967B22681CE}" type="presOf" srcId="{2EA87C6E-B934-4E05-92CE-11838CD1E152}" destId="{4179BA1F-3973-454C-9A78-CB1EF4B8CA74}" srcOrd="0" destOrd="0" presId="urn:microsoft.com/office/officeart/2005/8/layout/list1#1"/>
+    <dgm:cxn modelId="{46D20542-6C5E-4D03-A6FB-8CE872731BF4}" type="presOf" srcId="{53DC1395-671D-462A-85F1-9042DBAEE857}" destId="{01F17DE6-0642-40F7-998E-E5607FBDEB40}" srcOrd="1" destOrd="0" presId="urn:microsoft.com/office/officeart/2005/8/layout/list1#1"/>
+    <dgm:cxn modelId="{EA1C8D5A-12A8-4FF0-9902-445B7AEF5CE8}" type="presOf" srcId="{4DBED84C-00DD-467B-9258-D4072A339320}" destId="{94790145-DC59-4338-8EDF-D5A93440A467}" srcOrd="0" destOrd="0" presId="urn:microsoft.com/office/officeart/2005/8/layout/list1#1"/>
+    <dgm:cxn modelId="{4AF4187F-883D-4128-8EF6-444B06DBD080}" type="presOf" srcId="{70098AD3-5A16-4CD0-995D-EBE6D75C1CBE}" destId="{FF55E445-1FDC-4B0D-B09B-B7C23D2D7B99}" srcOrd="0" destOrd="0" presId="urn:microsoft.com/office/officeart/2005/8/layout/list1#1"/>
+    <dgm:cxn modelId="{2AE0668F-7182-4E7C-898B-415AFFE8C20C}" type="presOf" srcId="{161DC7CD-2A9C-494E-A3CB-C00629A94A16}" destId="{FF55E445-1FDC-4B0D-B09B-B7C23D2D7B99}" srcOrd="0" destOrd="2" presId="urn:microsoft.com/office/officeart/2005/8/layout/list1#1"/>
+    <dgm:cxn modelId="{84107492-A23F-4101-AD61-828CD67B32D0}" type="presOf" srcId="{FD6528C4-B993-4C3E-B58A-A589B3936723}" destId="{FF55E445-1FDC-4B0D-B09B-B7C23D2D7B99}" srcOrd="0" destOrd="1" presId="urn:microsoft.com/office/officeart/2005/8/layout/list1#1"/>
     <dgm:cxn modelId="{30A509B7-AD71-4EE6-95EF-7B54AC6B03D9}" srcId="{2EA87C6E-B934-4E05-92CE-11838CD1E152}" destId="{53DC1395-671D-462A-85F1-9042DBAEE857}" srcOrd="1" destOrd="0" parTransId="{ED6853BE-FB3B-4B16-9C50-685E1737CCD0}" sibTransId="{8516FDED-D365-4C41-AFE8-C357BA041995}"/>
     <dgm:cxn modelId="{018C73CE-6688-4F3F-AE00-C2DB525E87FE}" srcId="{53DC1395-671D-462A-85F1-9042DBAEE857}" destId="{FD6528C4-B993-4C3E-B58A-A589B3936723}" srcOrd="1" destOrd="0" parTransId="{421A0C26-3270-4ADD-8876-5F909ACDE2A7}" sibTransId="{A825E278-D54E-4863-872D-D5CE7C6722C3}"/>
     <dgm:cxn modelId="{F3A06BCF-670E-4C94-A6B2-664C718792BC}" srcId="{161DC7CD-2A9C-494E-A3CB-C00629A94A16}" destId="{17296CB8-9C76-4A49-9F9D-0C80D092B9C7}" srcOrd="0" destOrd="0" parTransId="{CA409A28-5D97-4E34-AE59-1C11AECBAC79}" sibTransId="{A33F6413-E18A-4071-90F9-4886A3DE896D}"/>
     <dgm:cxn modelId="{43FD1FD6-0FCB-43E6-B95B-FD1B3ABFA0B7}" srcId="{53DC1395-671D-462A-85F1-9042DBAEE857}" destId="{70098AD3-5A16-4CD0-995D-EBE6D75C1CBE}" srcOrd="0" destOrd="0" parTransId="{2C90661F-8AC4-42B4-9E61-26BDD680B877}" sibTransId="{54A2DAF0-A5C3-48FA-90B4-86C66B03274F}"/>
-    <dgm:cxn modelId="{E762A9D9-86D1-4B6A-BF28-0E6913727AC0}" type="presOf" srcId="{4DBED84C-00DD-467B-9258-D4072A339320}" destId="{C0EEAB04-3AAC-4259-BB72-5D809776985B}" srcOrd="1" destOrd="0" presId="urn:microsoft.com/office/officeart/2005/8/layout/list1"/>
+    <dgm:cxn modelId="{E762A9D9-86D1-4B6A-BF28-0E6913727AC0}" type="presOf" srcId="{4DBED84C-00DD-467B-9258-D4072A339320}" destId="{C0EEAB04-3AAC-4259-BB72-5D809776985B}" srcOrd="1" destOrd="0" presId="urn:microsoft.com/office/officeart/2005/8/layout/list1#1"/>
     <dgm:cxn modelId="{99F3FDEE-BDF9-4728-A424-132E418EFC70}" srcId="{2EA87C6E-B934-4E05-92CE-11838CD1E152}" destId="{4DBED84C-00DD-467B-9258-D4072A339320}" srcOrd="0" destOrd="0" parTransId="{8252ECEA-62AB-4828-8DA3-65022CD24637}" sibTransId="{C588BAC4-428C-457F-A3BA-61DCE356B7B0}"/>
-    <dgm:cxn modelId="{F54F4B84-2412-4312-9297-B93EE3A31682}" type="presParOf" srcId="{4179BA1F-3973-454C-9A78-CB1EF4B8CA74}" destId="{5192F002-9B89-4D47-AE62-DF20B386D065}" srcOrd="0" destOrd="0" presId="urn:microsoft.com/office/officeart/2005/8/layout/list1"/>
-    <dgm:cxn modelId="{F89B1C93-B4E2-4F2B-8696-CE3BEF808143}" type="presParOf" srcId="{5192F002-9B89-4D47-AE62-DF20B386D065}" destId="{94790145-DC59-4338-8EDF-D5A93440A467}" srcOrd="0" destOrd="0" presId="urn:microsoft.com/office/officeart/2005/8/layout/list1"/>
-    <dgm:cxn modelId="{BF9EDB34-CFFE-4104-A5B7-08722C05A26C}" type="presParOf" srcId="{5192F002-9B89-4D47-AE62-DF20B386D065}" destId="{C0EEAB04-3AAC-4259-BB72-5D809776985B}" srcOrd="1" destOrd="0" presId="urn:microsoft.com/office/officeart/2005/8/layout/list1"/>
-    <dgm:cxn modelId="{F4B8E4C1-FE5C-4D10-B12C-77D7256EA4B9}" type="presParOf" srcId="{4179BA1F-3973-454C-9A78-CB1EF4B8CA74}" destId="{5E2A6CA5-4FF8-4147-BC42-66137C5C9689}" srcOrd="1" destOrd="0" presId="urn:microsoft.com/office/officeart/2005/8/layout/list1"/>
-    <dgm:cxn modelId="{C6F195A8-DBE9-4DD0-91C1-5D4E683444C2}" type="presParOf" srcId="{4179BA1F-3973-454C-9A78-CB1EF4B8CA74}" destId="{F90DC9BF-EA9A-49A4-A0AA-E535E9DE5ED9}" srcOrd="2" destOrd="0" presId="urn:microsoft.com/office/officeart/2005/8/layout/list1"/>
-    <dgm:cxn modelId="{BF54E44E-D9C8-46E8-925B-69B729149AB2}" type="presParOf" srcId="{4179BA1F-3973-454C-9A78-CB1EF4B8CA74}" destId="{5D30DC1A-9996-42C4-B328-BA1F4B6209E0}" srcOrd="3" destOrd="0" presId="urn:microsoft.com/office/officeart/2005/8/layout/list1"/>
-    <dgm:cxn modelId="{495A63C8-49F9-40C8-9924-4CD3785F067F}" type="presParOf" srcId="{4179BA1F-3973-454C-9A78-CB1EF4B8CA74}" destId="{57BA0DDD-10E6-4642-8428-DE88CA1FFC96}" srcOrd="4" destOrd="0" presId="urn:microsoft.com/office/officeart/2005/8/layout/list1"/>
-    <dgm:cxn modelId="{B041956B-F782-4CB3-A2DC-AC5CAD8BE71E}" type="presParOf" srcId="{57BA0DDD-10E6-4642-8428-DE88CA1FFC96}" destId="{EDAF76F7-74CE-4BC5-A6FF-621F2E8A02C1}" srcOrd="0" destOrd="0" presId="urn:microsoft.com/office/officeart/2005/8/layout/list1"/>
-    <dgm:cxn modelId="{00B956ED-C51F-4841-B601-02E442E2102D}" type="presParOf" srcId="{57BA0DDD-10E6-4642-8428-DE88CA1FFC96}" destId="{01F17DE6-0642-40F7-998E-E5607FBDEB40}" srcOrd="1" destOrd="0" presId="urn:microsoft.com/office/officeart/2005/8/layout/list1"/>
-    <dgm:cxn modelId="{58232C9E-1D13-4661-B282-E8EA96C28025}" type="presParOf" srcId="{4179BA1F-3973-454C-9A78-CB1EF4B8CA74}" destId="{5EEE36AD-BBCC-4CA5-A1FA-27C467EB792E}" srcOrd="5" destOrd="0" presId="urn:microsoft.com/office/officeart/2005/8/layout/list1"/>
-    <dgm:cxn modelId="{84DA667E-8EE4-4A12-878D-93EA4CD3A8D9}" type="presParOf" srcId="{4179BA1F-3973-454C-9A78-CB1EF4B8CA74}" destId="{FF55E445-1FDC-4B0D-B09B-B7C23D2D7B99}" srcOrd="6" destOrd="0" presId="urn:microsoft.com/office/officeart/2005/8/layout/list1"/>
+    <dgm:cxn modelId="{F54F4B84-2412-4312-9297-B93EE3A31682}" type="presParOf" srcId="{4179BA1F-3973-454C-9A78-CB1EF4B8CA74}" destId="{5192F002-9B89-4D47-AE62-DF20B386D065}" srcOrd="0" destOrd="0" presId="urn:microsoft.com/office/officeart/2005/8/layout/list1#1"/>
+    <dgm:cxn modelId="{F89B1C93-B4E2-4F2B-8696-CE3BEF808143}" type="presParOf" srcId="{5192F002-9B89-4D47-AE62-DF20B386D065}" destId="{94790145-DC59-4338-8EDF-D5A93440A467}" srcOrd="0" destOrd="0" presId="urn:microsoft.com/office/officeart/2005/8/layout/list1#1"/>
+    <dgm:cxn modelId="{BF9EDB34-CFFE-4104-A5B7-08722C05A26C}" type="presParOf" srcId="{5192F002-9B89-4D47-AE62-DF20B386D065}" destId="{C0EEAB04-3AAC-4259-BB72-5D809776985B}" srcOrd="1" destOrd="0" presId="urn:microsoft.com/office/officeart/2005/8/layout/list1#1"/>
+    <dgm:cxn modelId="{F4B8E4C1-FE5C-4D10-B12C-77D7256EA4B9}" type="presParOf" srcId="{4179BA1F-3973-454C-9A78-CB1EF4B8CA74}" destId="{5E2A6CA5-4FF8-4147-BC42-66137C5C9689}" srcOrd="1" destOrd="0" presId="urn:microsoft.com/office/officeart/2005/8/layout/list1#1"/>
+    <dgm:cxn modelId="{C6F195A8-DBE9-4DD0-91C1-5D4E683444C2}" type="presParOf" srcId="{4179BA1F-3973-454C-9A78-CB1EF4B8CA74}" destId="{F90DC9BF-EA9A-49A4-A0AA-E535E9DE5ED9}" srcOrd="2" destOrd="0" presId="urn:microsoft.com/office/officeart/2005/8/layout/list1#1"/>
+    <dgm:cxn modelId="{BF54E44E-D9C8-46E8-925B-69B729149AB2}" type="presParOf" srcId="{4179BA1F-3973-454C-9A78-CB1EF4B8CA74}" destId="{5D30DC1A-9996-42C4-B328-BA1F4B6209E0}" srcOrd="3" destOrd="0" presId="urn:microsoft.com/office/officeart/2005/8/layout/list1#1"/>
+    <dgm:cxn modelId="{495A63C8-49F9-40C8-9924-4CD3785F067F}" type="presParOf" srcId="{4179BA1F-3973-454C-9A78-CB1EF4B8CA74}" destId="{57BA0DDD-10E6-4642-8428-DE88CA1FFC96}" srcOrd="4" destOrd="0" presId="urn:microsoft.com/office/officeart/2005/8/layout/list1#1"/>
+    <dgm:cxn modelId="{B041956B-F782-4CB3-A2DC-AC5CAD8BE71E}" type="presParOf" srcId="{57BA0DDD-10E6-4642-8428-DE88CA1FFC96}" destId="{EDAF76F7-74CE-4BC5-A6FF-621F2E8A02C1}" srcOrd="0" destOrd="0" presId="urn:microsoft.com/office/officeart/2005/8/layout/list1#1"/>
+    <dgm:cxn modelId="{00B956ED-C51F-4841-B601-02E442E2102D}" type="presParOf" srcId="{57BA0DDD-10E6-4642-8428-DE88CA1FFC96}" destId="{01F17DE6-0642-40F7-998E-E5607FBDEB40}" srcOrd="1" destOrd="0" presId="urn:microsoft.com/office/officeart/2005/8/layout/list1#1"/>
+    <dgm:cxn modelId="{58232C9E-1D13-4661-B282-E8EA96C28025}" type="presParOf" srcId="{4179BA1F-3973-454C-9A78-CB1EF4B8CA74}" destId="{5EEE36AD-BBCC-4CA5-A1FA-27C467EB792E}" srcOrd="5" destOrd="0" presId="urn:microsoft.com/office/officeart/2005/8/layout/list1#1"/>
+    <dgm:cxn modelId="{84DA667E-8EE4-4A12-878D-93EA4CD3A8D9}" type="presParOf" srcId="{4179BA1F-3973-454C-9A78-CB1EF4B8CA74}" destId="{FF55E445-1FDC-4B0D-B09B-B7C23D2D7B99}" srcOrd="6" destOrd="0" presId="urn:microsoft.com/office/officeart/2005/8/layout/list1#1"/>
   </dgm:cxnLst>
   <dgm:bg/>
   <dgm:whole/>
   <dgm:extLst>
     <a:ext uri="http://schemas.microsoft.com/office/drawing/2008/diagram">
-      <dsp:dataModelExt xmlns:dsp="http://schemas.microsoft.com/office/drawing/2008/diagram" relId="rId6" minVer="http://schemas.openxmlformats.org/drawingml/2006/diagram"/>
+      <dsp:dataModelExt xmlns:dsp="http://schemas.microsoft.com/office/drawing/2008/diagram" relId="rId7" minVer="http://schemas.openxmlformats.org/drawingml/2006/diagram"/>
     </a:ext>
   </dgm:extLst>
 </dgm:dataModel>
 </file>
 
 <file path=ppt/diagrams/drawing1.xml><?xml version="1.0" encoding="utf-8"?>
-<dsp:drawing xmlns:dgm="http://schemas.openxmlformats.org/drawingml/2006/diagram" xmlns:dsp="http://schemas.microsoft.com/office/drawing/2008/diagram" xmlns:a="http://schemas.openxmlformats.org/drawingml/2006/main" xmlns:r="http://schemas.openxmlformats.org/officeDocument/2006/relationships">
+<dsp:drawing xmlns:dgm="http://schemas.openxmlformats.org/drawingml/2006/diagram" xmlns:dsp="http://schemas.microsoft.com/office/drawing/2008/diagram" xmlns:a="http://schemas.openxmlformats.org/drawingml/2006/main">
   <dsp:spTree>
     <dsp:nvGrpSpPr>
-      <dsp:cNvPr id="2" name="组合 1"/>
+      <dsp:cNvPr id="0" name=""/>
       <dsp:cNvGrpSpPr/>
     </dsp:nvGrpSpPr>
-    <dsp:grpSpPr>
-      <a:xfrm>
-        <a:off x="0" y="0"/>
-        <a:ext cx="6912245" cy="5536883"/>
-        <a:chOff x="0" y="0"/>
-        <a:chExt cx="6912245" cy="5536883"/>
-      </a:xfrm>
-    </dsp:grpSpPr>
+    <dsp:grpSpPr/>
     <dsp:sp modelId="{F90DC9BF-EA9A-49A4-A0AA-E535E9DE5ED9}">
       <dsp:nvSpPr>
-        <dsp:cNvPr id="5" name="矩形 4"/>
+        <dsp:cNvPr id="0" name=""/>
         <dsp:cNvSpPr/>
       </dsp:nvSpPr>
-      <dsp:spPr bwMode="white">
+      <dsp:spPr>
         <a:xfrm>
-          <a:off x="0" y="923657"/>
+          <a:off x="0" y="677741"/>
           <a:ext cx="6912245" cy="579600"/>
         </a:xfrm>
         <a:prstGeom prst="rect">
           <a:avLst/>
         </a:prstGeom>
+        <a:solidFill>
+          <a:schemeClr val="lt1">
+            <a:alpha val="90000"/>
+            <a:hueOff val="0"/>
+            <a:satOff val="0"/>
+            <a:lumOff val="0"/>
+            <a:alphaOff val="0"/>
+          </a:schemeClr>
+        </a:solidFill>
+        <a:ln w="12700" cap="flat" cmpd="sng" algn="ctr">
+          <a:solidFill>
+            <a:schemeClr val="accent6">
+              <a:hueOff val="0"/>
+              <a:satOff val="0"/>
+              <a:lumOff val="0"/>
+              <a:alphaOff val="0"/>
+            </a:schemeClr>
+          </a:solidFill>
+          <a:prstDash val="solid"/>
+          <a:miter lim="800000"/>
+        </a:ln>
+        <a:effectLst/>
       </dsp:spPr>
       <dsp:style>
         <a:lnRef idx="2">
-          <a:schemeClr val="accent6"/>
+          <a:scrgbClr r="0" g="0" b="0"/>
         </a:lnRef>
         <a:fillRef idx="1">
-          <a:schemeClr val="lt1">
-            <a:alpha val="90000"/>
-          </a:schemeClr>
+          <a:scrgbClr r="0" g="0" b="0"/>
         </a:fillRef>
         <a:effectRef idx="0">
           <a:scrgbClr r="0" g="0" b="0"/>
         </a:effectRef>
         <a:fontRef idx="minor"/>
       </dsp:style>
-      <dsp:txBody>
-        <a:bodyPr lIns="536467" tIns="187452" rIns="536467" bIns="64008" anchor="t"/>
-        <a:lstStyle>
-          <a:lvl1pPr algn="l">
-            <a:defRPr sz="900"/>
-          </a:lvl1pPr>
-          <a:lvl2pPr marL="57150" indent="-57150" algn="l">
-            <a:defRPr sz="900"/>
-          </a:lvl2pPr>
-          <a:lvl3pPr marL="114300" indent="-57150" algn="l">
-            <a:defRPr sz="900"/>
-          </a:lvl3pPr>
-          <a:lvl4pPr marL="171450" indent="-57150" algn="l">
-            <a:defRPr sz="900"/>
-          </a:lvl4pPr>
-          <a:lvl5pPr marL="228600" indent="-57150" algn="l">
-            <a:defRPr sz="900"/>
-          </a:lvl5pPr>
-          <a:lvl6pPr marL="285750" indent="-57150" algn="l">
-            <a:defRPr sz="900"/>
-          </a:lvl6pPr>
-          <a:lvl7pPr marL="342900" indent="-57150" algn="l">
-            <a:defRPr sz="900"/>
-          </a:lvl7pPr>
-          <a:lvl8pPr marL="400050" indent="-57150" algn="l">
-            <a:defRPr sz="900"/>
-          </a:lvl8pPr>
-          <a:lvl9pPr marL="457200" indent="-57150" algn="l">
-            <a:defRPr sz="900"/>
-          </a:lvl9pPr>
-        </a:lstStyle>
-        <a:p>
-          <a:endParaRPr>
-            <a:solidFill>
-              <a:schemeClr val="dk1"/>
-            </a:solidFill>
-          </a:endParaRPr>
-        </a:p>
-      </dsp:txBody>
-      <dsp:txXfrm>
-        <a:off x="0" y="923657"/>
-        <a:ext cx="6912245" cy="579600"/>
-      </dsp:txXfrm>
     </dsp:sp>
     <dsp:sp modelId="{C0EEAB04-3AAC-4259-BB72-5D809776985B}">
       <dsp:nvSpPr>
-        <dsp:cNvPr id="4" name="圆角矩形 3"/>
+        <dsp:cNvPr id="0" name=""/>
         <dsp:cNvSpPr/>
       </dsp:nvSpPr>
-      <dsp:spPr bwMode="white">
+      <dsp:spPr>
         <a:xfrm>
-          <a:off x="345612" y="584177"/>
-          <a:ext cx="4838572" cy="678960"/>
+          <a:off x="345612" y="338261"/>
+          <a:ext cx="4838571" cy="678960"/>
         </a:xfrm>
         <a:prstGeom prst="roundRect">
           <a:avLst/>
         </a:prstGeom>
+        <a:solidFill>
+          <a:schemeClr val="accent6">
+            <a:hueOff val="0"/>
+            <a:satOff val="0"/>
+            <a:lumOff val="0"/>
+            <a:alphaOff val="0"/>
+          </a:schemeClr>
+        </a:solidFill>
+        <a:ln w="12700" cap="flat" cmpd="sng" algn="ctr">
+          <a:solidFill>
+            <a:schemeClr val="lt1">
+              <a:hueOff val="0"/>
+              <a:satOff val="0"/>
+              <a:lumOff val="0"/>
+              <a:alphaOff val="0"/>
+            </a:schemeClr>
+          </a:solidFill>
+          <a:prstDash val="solid"/>
+          <a:miter lim="800000"/>
+        </a:ln>
+        <a:effectLst/>
       </dsp:spPr>
       <dsp:style>
         <a:lnRef idx="2">
-          <a:schemeClr val="lt1"/>
+          <a:scrgbClr r="0" g="0" b="0"/>
         </a:lnRef>
         <a:fillRef idx="1">
-          <a:schemeClr val="accent6"/>
+          <a:scrgbClr r="0" g="0" b="0"/>
         </a:fillRef>
         <a:effectRef idx="0">
           <a:scrgbClr r="0" g="0" b="0"/>
@@ -1426,40 +1417,14 @@
         </a:fontRef>
       </dsp:style>
       <dsp:txBody>
-        <a:bodyPr lIns="182886" tIns="0" rIns="182886" bIns="0" anchor="ctr"/>
-        <a:lstStyle>
-          <a:lvl1pPr algn="l">
-            <a:defRPr sz="900"/>
-          </a:lvl1pPr>
-          <a:lvl2pPr marL="57150" indent="-57150" algn="l">
-            <a:defRPr sz="700"/>
-          </a:lvl2pPr>
-          <a:lvl3pPr marL="114300" indent="-57150" algn="l">
-            <a:defRPr sz="700"/>
-          </a:lvl3pPr>
-          <a:lvl4pPr marL="171450" indent="-57150" algn="l">
-            <a:defRPr sz="700"/>
-          </a:lvl4pPr>
-          <a:lvl5pPr marL="228600" indent="-57150" algn="l">
-            <a:defRPr sz="700"/>
-          </a:lvl5pPr>
-          <a:lvl6pPr marL="285750" indent="-57150" algn="l">
-            <a:defRPr sz="700"/>
-          </a:lvl6pPr>
-          <a:lvl7pPr marL="342900" indent="-57150" algn="l">
-            <a:defRPr sz="700"/>
-          </a:lvl7pPr>
-          <a:lvl8pPr marL="400050" indent="-57150" algn="l">
-            <a:defRPr sz="700"/>
-          </a:lvl8pPr>
-          <a:lvl9pPr marL="457200" indent="-57150" algn="l">
-            <a:defRPr sz="700"/>
-          </a:lvl9pPr>
-        </a:lstStyle>
+        <a:bodyPr spcFirstLastPara="0" vert="horz" wrap="square" lIns="182886" tIns="0" rIns="182886" bIns="0" numCol="1" spcCol="1270" anchor="ctr" anchorCtr="0">
+          <a:noAutofit/>
+        </a:bodyPr>
+        <a:lstStyle/>
         <a:p>
-          <a:pPr lvl="0">
+          <a:pPr marL="0" lvl="0" indent="0" algn="l" defTabSz="1022350">
             <a:lnSpc>
-              <a:spcPct val="100000"/>
+              <a:spcPct val="90000"/>
             </a:lnSpc>
             <a:spcBef>
               <a:spcPct val="0"/>
@@ -1467,49 +1432,70 @@
             <a:spcAft>
               <a:spcPct val="35000"/>
             </a:spcAft>
+            <a:buNone/>
           </a:pPr>
           <a:r>
-            <a:rPr lang="zh-CN"/>
+            <a:rPr lang="zh-CN" sz="2300" kern="1200"/>
             <a:t>和敏捷</a:t>
           </a:r>
           <a:r>
-            <a:rPr lang="en-US"/>
+            <a:rPr lang="en-US" sz="2300" kern="1200"/>
             <a:t>/MSF Persona/Scenario </a:t>
           </a:r>
           <a:r>
-            <a:rPr lang="zh-CN"/>
+            <a:rPr lang="zh-CN" sz="2300" kern="1200"/>
             <a:t>类似</a:t>
           </a:r>
-          <a:endParaRPr lang="en-US"/>
+          <a:endParaRPr lang="en-US" sz="2300" kern="1200"/>
         </a:p>
       </dsp:txBody>
       <dsp:txXfrm>
-        <a:off x="345612" y="584177"/>
-        <a:ext cx="4838572" cy="678960"/>
+        <a:off x="378756" y="371405"/>
+        <a:ext cx="4772283" cy="612672"/>
       </dsp:txXfrm>
     </dsp:sp>
     <dsp:sp modelId="{FF55E445-1FDC-4B0D-B09B-B7C23D2D7B99}">
       <dsp:nvSpPr>
-        <dsp:cNvPr id="8" name="矩形 7"/>
+        <dsp:cNvPr id="0" name=""/>
         <dsp:cNvSpPr/>
       </dsp:nvSpPr>
-      <dsp:spPr bwMode="white">
+      <dsp:spPr>
         <a:xfrm>
-          <a:off x="0" y="1966937"/>
-          <a:ext cx="6912245" cy="2985770"/>
+          <a:off x="0" y="1721021"/>
+          <a:ext cx="6912245" cy="3477600"/>
         </a:xfrm>
         <a:prstGeom prst="rect">
           <a:avLst/>
         </a:prstGeom>
+        <a:solidFill>
+          <a:schemeClr val="lt1">
+            <a:alpha val="90000"/>
+            <a:hueOff val="0"/>
+            <a:satOff val="0"/>
+            <a:lumOff val="0"/>
+            <a:alphaOff val="0"/>
+          </a:schemeClr>
+        </a:solidFill>
+        <a:ln w="12700" cap="flat" cmpd="sng" algn="ctr">
+          <a:solidFill>
+            <a:schemeClr val="accent6">
+              <a:hueOff val="0"/>
+              <a:satOff val="0"/>
+              <a:lumOff val="0"/>
+              <a:alphaOff val="0"/>
+            </a:schemeClr>
+          </a:solidFill>
+          <a:prstDash val="solid"/>
+          <a:miter lim="800000"/>
+        </a:ln>
+        <a:effectLst/>
       </dsp:spPr>
       <dsp:style>
         <a:lnRef idx="2">
-          <a:schemeClr val="accent6"/>
+          <a:scrgbClr r="0" g="0" b="0"/>
         </a:lnRef>
         <a:fillRef idx="1">
-          <a:schemeClr val="lt1">
-            <a:alpha val="90000"/>
-          </a:schemeClr>
+          <a:scrgbClr r="0" g="0" b="0"/>
         </a:fillRef>
         <a:effectRef idx="0">
           <a:scrgbClr r="0" g="0" b="0"/>
@@ -1517,40 +1503,14 @@
         <a:fontRef idx="minor"/>
       </dsp:style>
       <dsp:txBody>
-        <a:bodyPr lIns="536467" tIns="187452" rIns="536467" bIns="64008" anchor="t"/>
-        <a:lstStyle>
-          <a:lvl1pPr algn="l">
-            <a:defRPr sz="900"/>
-          </a:lvl1pPr>
-          <a:lvl2pPr marL="57150" indent="-57150" algn="l">
-            <a:defRPr sz="900"/>
-          </a:lvl2pPr>
-          <a:lvl3pPr marL="114300" indent="-57150" algn="l">
-            <a:defRPr sz="900"/>
-          </a:lvl3pPr>
-          <a:lvl4pPr marL="171450" indent="-57150" algn="l">
-            <a:defRPr sz="900"/>
-          </a:lvl4pPr>
-          <a:lvl5pPr marL="228600" indent="-57150" algn="l">
-            <a:defRPr sz="900"/>
-          </a:lvl5pPr>
-          <a:lvl6pPr marL="285750" indent="-57150" algn="l">
-            <a:defRPr sz="900"/>
-          </a:lvl6pPr>
-          <a:lvl7pPr marL="342900" indent="-57150" algn="l">
-            <a:defRPr sz="900"/>
-          </a:lvl7pPr>
-          <a:lvl8pPr marL="400050" indent="-57150" algn="l">
-            <a:defRPr sz="900"/>
-          </a:lvl8pPr>
-          <a:lvl9pPr marL="457200" indent="-57150" algn="l">
-            <a:defRPr sz="900"/>
-          </a:lvl9pPr>
-        </a:lstStyle>
+        <a:bodyPr spcFirstLastPara="0" vert="horz" wrap="square" lIns="536467" tIns="479044" rIns="536467" bIns="163576" numCol="1" spcCol="1270" anchor="t" anchorCtr="0">
+          <a:noAutofit/>
+        </a:bodyPr>
+        <a:lstStyle/>
         <a:p>
-          <a:pPr lvl="1">
+          <a:pPr marL="228600" lvl="1" indent="-228600" algn="l" defTabSz="1022350">
             <a:lnSpc>
-              <a:spcPct val="100000"/>
+              <a:spcPct val="90000"/>
             </a:lnSpc>
             <a:spcBef>
               <a:spcPct val="0"/>
@@ -1561,55 +1521,31 @@
             <a:buChar char="•"/>
           </a:pPr>
           <a:r>
-            <a:rPr lang="zh-CN">
-              <a:solidFill>
-                <a:schemeClr val="dk1"/>
-              </a:solidFill>
-            </a:rPr>
+            <a:rPr lang="zh-CN" sz="2300" kern="1200"/>
             <a:t>故事</a:t>
           </a:r>
           <a:r>
-            <a:rPr lang="en-US">
-              <a:solidFill>
-                <a:schemeClr val="dk1"/>
-              </a:solidFill>
-            </a:rPr>
+            <a:rPr lang="en-US" sz="2300" kern="1200"/>
             <a:t>/</a:t>
           </a:r>
           <a:r>
-            <a:rPr lang="zh-CN">
-              <a:solidFill>
-                <a:schemeClr val="dk1"/>
-              </a:solidFill>
-            </a:rPr>
+            <a:rPr lang="zh-CN" sz="2300" kern="1200"/>
             <a:t>任务</a:t>
           </a:r>
           <a:r>
-            <a:rPr lang="en-US">
-              <a:solidFill>
-                <a:schemeClr val="dk1"/>
-              </a:solidFill>
-            </a:rPr>
+            <a:rPr lang="en-US" sz="2300" kern="1200"/>
             <a:t>/</a:t>
           </a:r>
           <a:r>
-            <a:rPr lang="zh-CN">
-              <a:solidFill>
-                <a:schemeClr val="dk1"/>
-              </a:solidFill>
-            </a:rPr>
+            <a:rPr lang="zh-CN" sz="2300" kern="1200"/>
             <a:t>场景非常适合交互式的系统。但是对其他类型的需求（算法，效率，安全性，系统）不适用。 </a:t>
           </a:r>
-          <a:endParaRPr lang="en-US">
-            <a:solidFill>
-              <a:schemeClr val="dk1"/>
-            </a:solidFill>
-          </a:endParaRPr>
+          <a:endParaRPr lang="en-US" sz="2300" kern="1200"/>
         </a:p>
         <a:p>
-          <a:pPr lvl="1">
+          <a:pPr marL="228600" lvl="1" indent="-228600" algn="l" defTabSz="1022350">
             <a:lnSpc>
-              <a:spcPct val="100000"/>
+              <a:spcPct val="90000"/>
             </a:lnSpc>
             <a:spcBef>
               <a:spcPct val="0"/>
@@ -1620,23 +1556,15 @@
             <a:buChar char="•"/>
           </a:pPr>
           <a:r>
-            <a:rPr lang="zh-CN">
-              <a:solidFill>
-                <a:schemeClr val="dk1"/>
-              </a:solidFill>
-            </a:rPr>
+            <a:rPr lang="zh-CN" sz="2300" kern="1200"/>
             <a:t>故事的粒度没有标准</a:t>
           </a:r>
-          <a:endParaRPr lang="en-US">
-            <a:solidFill>
-              <a:schemeClr val="dk1"/>
-            </a:solidFill>
-          </a:endParaRPr>
+          <a:endParaRPr lang="en-US" sz="2300" kern="1200"/>
         </a:p>
         <a:p>
-          <a:pPr lvl="1">
+          <a:pPr marL="228600" lvl="1" indent="-228600" algn="l" defTabSz="1022350">
             <a:lnSpc>
-              <a:spcPct val="100000"/>
+              <a:spcPct val="90000"/>
             </a:lnSpc>
             <a:spcBef>
               <a:spcPct val="0"/>
@@ -1647,39 +1575,23 @@
             <a:buChar char="•"/>
           </a:pPr>
           <a:r>
-            <a:rPr lang="zh-CN">
-              <a:solidFill>
-                <a:schemeClr val="dk1"/>
-              </a:solidFill>
-            </a:rPr>
+            <a:rPr lang="zh-CN" sz="2300" kern="1200"/>
             <a:t>如何把</a:t>
           </a:r>
           <a:r>
-            <a:rPr lang="en-US">
-              <a:solidFill>
-                <a:schemeClr val="dk1"/>
-              </a:solidFill>
-            </a:rPr>
+            <a:rPr lang="en-US" sz="2300" kern="1200"/>
             <a:t>UI </a:t>
           </a:r>
           <a:r>
-            <a:rPr lang="zh-CN">
-              <a:solidFill>
-                <a:schemeClr val="dk1"/>
-              </a:solidFill>
-            </a:rPr>
+            <a:rPr lang="zh-CN" sz="2300" kern="1200"/>
             <a:t>的细节嵌入每个故事中？</a:t>
           </a:r>
-          <a:endParaRPr lang="en-US">
-            <a:solidFill>
-              <a:schemeClr val="dk1"/>
-            </a:solidFill>
-          </a:endParaRPr>
+          <a:endParaRPr lang="en-US" sz="2300" kern="1200"/>
         </a:p>
         <a:p>
-          <a:pPr lvl="2">
+          <a:pPr marL="457200" lvl="2" indent="-228600" algn="l" defTabSz="1022350">
             <a:lnSpc>
-              <a:spcPct val="100000"/>
+              <a:spcPct val="90000"/>
             </a:lnSpc>
             <a:spcBef>
               <a:spcPct val="0"/>
@@ -1690,62 +1602,67 @@
             <a:buChar char="•"/>
           </a:pPr>
           <a:r>
-            <a:rPr lang="en-US">
-              <a:solidFill>
-                <a:schemeClr val="dk1"/>
-              </a:solidFill>
-            </a:rPr>
+            <a:rPr lang="en-US" sz="2300" kern="1200"/>
             <a:t>User Case </a:t>
           </a:r>
           <a:r>
-            <a:rPr lang="en-US">
-              <a:solidFill>
-                <a:schemeClr val="dk1"/>
-              </a:solidFill>
+            <a:rPr lang="en-US" sz="2300" kern="1200">
               <a:sym typeface="Wingdings" panose="05000000000000000000" pitchFamily="2" charset="2"/>
             </a:rPr>
             <a:t></a:t>
           </a:r>
           <a:r>
-            <a:rPr lang="en-US">
-              <a:solidFill>
-                <a:schemeClr val="dk1"/>
-              </a:solidFill>
-            </a:rPr>
+            <a:rPr lang="en-US" sz="2300" kern="1200"/>
             <a:t> User Case Storyboard </a:t>
           </a:r>
-          <a:endParaRPr>
-            <a:solidFill>
-              <a:schemeClr val="dk1"/>
-            </a:solidFill>
-          </a:endParaRPr>
         </a:p>
       </dsp:txBody>
       <dsp:txXfrm>
-        <a:off x="0" y="1966937"/>
-        <a:ext cx="6912245" cy="2985770"/>
+        <a:off x="0" y="1721021"/>
+        <a:ext cx="6912245" cy="3477600"/>
       </dsp:txXfrm>
     </dsp:sp>
     <dsp:sp modelId="{01F17DE6-0642-40F7-998E-E5607FBDEB40}">
       <dsp:nvSpPr>
-        <dsp:cNvPr id="7" name="圆角矩形 6"/>
+        <dsp:cNvPr id="0" name=""/>
         <dsp:cNvSpPr/>
       </dsp:nvSpPr>
-      <dsp:spPr bwMode="white">
+      <dsp:spPr>
         <a:xfrm>
-          <a:off x="345612" y="1627457"/>
-          <a:ext cx="4838572" cy="678960"/>
+          <a:off x="345612" y="1381541"/>
+          <a:ext cx="4838571" cy="678960"/>
         </a:xfrm>
         <a:prstGeom prst="roundRect">
           <a:avLst/>
         </a:prstGeom>
+        <a:solidFill>
+          <a:schemeClr val="accent6">
+            <a:hueOff val="0"/>
+            <a:satOff val="0"/>
+            <a:lumOff val="0"/>
+            <a:alphaOff val="0"/>
+          </a:schemeClr>
+        </a:solidFill>
+        <a:ln w="12700" cap="flat" cmpd="sng" algn="ctr">
+          <a:solidFill>
+            <a:schemeClr val="lt1">
+              <a:hueOff val="0"/>
+              <a:satOff val="0"/>
+              <a:lumOff val="0"/>
+              <a:alphaOff val="0"/>
+            </a:schemeClr>
+          </a:solidFill>
+          <a:prstDash val="solid"/>
+          <a:miter lim="800000"/>
+        </a:ln>
+        <a:effectLst/>
       </dsp:spPr>
       <dsp:style>
         <a:lnRef idx="2">
-          <a:schemeClr val="lt1"/>
+          <a:scrgbClr r="0" g="0" b="0"/>
         </a:lnRef>
         <a:fillRef idx="1">
-          <a:schemeClr val="accent6"/>
+          <a:scrgbClr r="0" g="0" b="0"/>
         </a:fillRef>
         <a:effectRef idx="0">
           <a:scrgbClr r="0" g="0" b="0"/>
@@ -1755,40 +1672,14 @@
         </a:fontRef>
       </dsp:style>
       <dsp:txBody>
-        <a:bodyPr lIns="182886" tIns="0" rIns="182886" bIns="0" anchor="ctr"/>
-        <a:lstStyle>
-          <a:lvl1pPr algn="l">
-            <a:defRPr sz="900"/>
-          </a:lvl1pPr>
-          <a:lvl2pPr marL="57150" indent="-57150" algn="l">
-            <a:defRPr sz="700"/>
-          </a:lvl2pPr>
-          <a:lvl3pPr marL="114300" indent="-57150" algn="l">
-            <a:defRPr sz="700"/>
-          </a:lvl3pPr>
-          <a:lvl4pPr marL="171450" indent="-57150" algn="l">
-            <a:defRPr sz="700"/>
-          </a:lvl4pPr>
-          <a:lvl5pPr marL="228600" indent="-57150" algn="l">
-            <a:defRPr sz="700"/>
-          </a:lvl5pPr>
-          <a:lvl6pPr marL="285750" indent="-57150" algn="l">
-            <a:defRPr sz="700"/>
-          </a:lvl6pPr>
-          <a:lvl7pPr marL="342900" indent="-57150" algn="l">
-            <a:defRPr sz="700"/>
-          </a:lvl7pPr>
-          <a:lvl8pPr marL="400050" indent="-57150" algn="l">
-            <a:defRPr sz="700"/>
-          </a:lvl8pPr>
-          <a:lvl9pPr marL="457200" indent="-57150" algn="l">
-            <a:defRPr sz="700"/>
-          </a:lvl9pPr>
-        </a:lstStyle>
+        <a:bodyPr spcFirstLastPara="0" vert="horz" wrap="square" lIns="182886" tIns="0" rIns="182886" bIns="0" numCol="1" spcCol="1270" anchor="ctr" anchorCtr="0">
+          <a:noAutofit/>
+        </a:bodyPr>
+        <a:lstStyle/>
         <a:p>
-          <a:pPr lvl="0">
+          <a:pPr marL="0" lvl="0" indent="0" algn="l" defTabSz="1022350">
             <a:lnSpc>
-              <a:spcPct val="100000"/>
+              <a:spcPct val="90000"/>
             </a:lnSpc>
             <a:spcBef>
               <a:spcPct val="0"/>
@@ -1796,55 +1687,18 @@
             <a:spcAft>
               <a:spcPct val="35000"/>
             </a:spcAft>
+            <a:buNone/>
           </a:pPr>
           <a:r>
-            <a:rPr lang="zh-CN"/>
+            <a:rPr lang="zh-CN" sz="2300" kern="1200"/>
             <a:t>局限性</a:t>
           </a:r>
-          <a:endParaRPr lang="en-US"/>
+          <a:endParaRPr lang="en-US" sz="2300" kern="1200"/>
         </a:p>
       </dsp:txBody>
       <dsp:txXfrm>
-        <a:off x="345612" y="1627457"/>
-        <a:ext cx="4838572" cy="678960"/>
-      </dsp:txXfrm>
-    </dsp:sp>
-    <dsp:sp modelId="{94790145-DC59-4338-8EDF-D5A93440A467}">
-      <dsp:nvSpPr>
-        <dsp:cNvPr id="3" name="矩形 2" hidden="1"/>
-        <dsp:cNvSpPr/>
-      </dsp:nvSpPr>
-      <dsp:spPr>
-        <a:xfrm>
-          <a:off x="0" y="584177"/>
-          <a:ext cx="345612" cy="678960"/>
-        </a:xfrm>
-        <a:prstGeom prst="rect">
-          <a:avLst/>
-        </a:prstGeom>
-      </dsp:spPr>
-      <dsp:txXfrm>
-        <a:off x="0" y="584177"/>
-        <a:ext cx="345612" cy="678960"/>
-      </dsp:txXfrm>
-    </dsp:sp>
-    <dsp:sp modelId="{EDAF76F7-74CE-4BC5-A6FF-621F2E8A02C1}">
-      <dsp:nvSpPr>
-        <dsp:cNvPr id="6" name="矩形 5" hidden="1"/>
-        <dsp:cNvSpPr/>
-      </dsp:nvSpPr>
-      <dsp:spPr>
-        <a:xfrm>
-          <a:off x="0" y="1627457"/>
-          <a:ext cx="345612" cy="678960"/>
-        </a:xfrm>
-        <a:prstGeom prst="rect">
-          <a:avLst/>
-        </a:prstGeom>
-      </dsp:spPr>
-      <dsp:txXfrm>
-        <a:off x="0" y="1627457"/>
-        <a:ext cx="345612" cy="678960"/>
+        <a:off x="378756" y="1414685"/>
+        <a:ext cx="4772283" cy="612672"/>
       </dsp:txXfrm>
     </dsp:sp>
   </dsp:spTree>
@@ -1852,7 +1706,7 @@
 </file>
 
 <file path=ppt/diagrams/layout1.xml><?xml version="1.0" encoding="utf-8"?>
-<dgm:layoutDef xmlns:dgm="http://schemas.openxmlformats.org/drawingml/2006/diagram" xmlns:a="http://schemas.openxmlformats.org/drawingml/2006/main" uniqueId="urn:microsoft.com/office/officeart/2005/8/layout/list1">
+<dgm:layoutDef xmlns:dgm="http://schemas.openxmlformats.org/drawingml/2006/diagram" xmlns:a="http://schemas.openxmlformats.org/drawingml/2006/main" uniqueId="urn:microsoft.com/office/officeart/2005/8/layout/list1#1">
   <dgm:title val=""/>
   <dgm:desc val=""/>
   <dgm:catLst>
@@ -2077,7 +1931,7 @@
 </file>
 
 <file path=ppt/diagrams/quickStyle1.xml><?xml version="1.0" encoding="utf-8"?>
-<dgm:styleDef xmlns:dgm="http://schemas.openxmlformats.org/drawingml/2006/diagram" xmlns:a="http://schemas.openxmlformats.org/drawingml/2006/main" uniqueId="urn:microsoft.com/office/officeart/2005/8/quickstyle/simple1">
+<dgm:styleDef xmlns:dgm="http://schemas.openxmlformats.org/drawingml/2006/diagram" xmlns:a="http://schemas.openxmlformats.org/drawingml/2006/main" uniqueId="urn:microsoft.com/office/officeart/2005/8/quickstyle/simple1#9">
   <dgm:title val=""/>
   <dgm:desc val=""/>
   <dgm:catLst>
@@ -2092,6 +1946,7 @@
       <a:camera prst="orthographicFront"/>
       <a:lightRig rig="threePt" dir="t"/>
     </dgm:scene3d>
+    <dgm:sp3d/>
     <dgm:txPr/>
     <dgm:style>
       <a:lnRef idx="2">
@@ -2111,6 +1966,7 @@
       <a:camera prst="orthographicFront"/>
       <a:lightRig rig="threePt" dir="t"/>
     </dgm:scene3d>
+    <dgm:sp3d/>
     <dgm:txPr/>
     <dgm:style>
       <a:lnRef idx="2">
@@ -2130,6 +1986,7 @@
       <a:camera prst="orthographicFront"/>
       <a:lightRig rig="threePt" dir="t"/>
     </dgm:scene3d>
+    <dgm:sp3d/>
     <dgm:txPr/>
     <dgm:style>
       <a:lnRef idx="2">
@@ -2149,6 +2006,7 @@
       <a:camera prst="orthographicFront"/>
       <a:lightRig rig="threePt" dir="t"/>
     </dgm:scene3d>
+    <dgm:sp3d/>
     <dgm:txPr/>
     <dgm:style>
       <a:lnRef idx="2">
@@ -2170,6 +2028,7 @@
       <a:camera prst="orthographicFront"/>
       <a:lightRig rig="threePt" dir="t"/>
     </dgm:scene3d>
+    <dgm:sp3d/>
     <dgm:txPr/>
     <dgm:style>
       <a:lnRef idx="2">
@@ -2191,6 +2050,7 @@
       <a:camera prst="orthographicFront"/>
       <a:lightRig rig="threePt" dir="t"/>
     </dgm:scene3d>
+    <dgm:sp3d/>
     <dgm:txPr/>
     <dgm:style>
       <a:lnRef idx="2">
@@ -2212,6 +2072,7 @@
       <a:camera prst="orthographicFront"/>
       <a:lightRig rig="threePt" dir="t"/>
     </dgm:scene3d>
+    <dgm:sp3d/>
     <dgm:txPr/>
     <dgm:style>
       <a:lnRef idx="2">
@@ -2233,6 +2094,7 @@
       <a:camera prst="orthographicFront"/>
       <a:lightRig rig="threePt" dir="t"/>
     </dgm:scene3d>
+    <dgm:sp3d/>
     <dgm:txPr/>
     <dgm:style>
       <a:lnRef idx="2">
@@ -2254,6 +2116,7 @@
       <a:camera prst="orthographicFront"/>
       <a:lightRig rig="threePt" dir="t"/>
     </dgm:scene3d>
+    <dgm:sp3d/>
     <dgm:txPr/>
     <dgm:style>
       <a:lnRef idx="2">
@@ -2275,6 +2138,7 @@
       <a:camera prst="orthographicFront"/>
       <a:lightRig rig="threePt" dir="t"/>
     </dgm:scene3d>
+    <dgm:sp3d/>
     <dgm:txPr/>
     <dgm:style>
       <a:lnRef idx="2">
@@ -2294,6 +2158,7 @@
       <a:camera prst="orthographicFront"/>
       <a:lightRig rig="threePt" dir="t"/>
     </dgm:scene3d>
+    <dgm:sp3d/>
     <dgm:txPr/>
     <dgm:style>
       <a:lnRef idx="2">
@@ -2313,6 +2178,7 @@
       <a:camera prst="orthographicFront"/>
       <a:lightRig rig="threePt" dir="t"/>
     </dgm:scene3d>
+    <dgm:sp3d/>
     <dgm:txPr/>
     <dgm:style>
       <a:lnRef idx="2">
@@ -2332,6 +2198,7 @@
       <a:camera prst="orthographicFront"/>
       <a:lightRig rig="threePt" dir="t"/>
     </dgm:scene3d>
+    <dgm:sp3d/>
     <dgm:txPr/>
     <dgm:style>
       <a:lnRef idx="0">
@@ -2351,6 +2218,7 @@
       <a:camera prst="orthographicFront"/>
       <a:lightRig rig="threePt" dir="t"/>
     </dgm:scene3d>
+    <dgm:sp3d/>
     <dgm:txPr/>
     <dgm:style>
       <a:lnRef idx="0">
@@ -2372,6 +2240,7 @@
       <a:camera prst="orthographicFront"/>
       <a:lightRig rig="threePt" dir="t"/>
     </dgm:scene3d>
+    <dgm:sp3d/>
     <dgm:txPr/>
     <dgm:style>
       <a:lnRef idx="2">
@@ -2391,6 +2260,7 @@
       <a:camera prst="orthographicFront"/>
       <a:lightRig rig="threePt" dir="t"/>
     </dgm:scene3d>
+    <dgm:sp3d/>
     <dgm:txPr/>
     <dgm:style>
       <a:lnRef idx="2">
@@ -2410,6 +2280,7 @@
       <a:camera prst="orthographicFront"/>
       <a:lightRig rig="threePt" dir="t"/>
     </dgm:scene3d>
+    <dgm:sp3d/>
     <dgm:txPr/>
     <dgm:style>
       <a:lnRef idx="0">
@@ -2429,6 +2300,7 @@
       <a:camera prst="orthographicFront"/>
       <a:lightRig rig="threePt" dir="t"/>
     </dgm:scene3d>
+    <dgm:sp3d/>
     <dgm:txPr/>
     <dgm:style>
       <a:lnRef idx="2">
@@ -2448,6 +2320,7 @@
       <a:camera prst="orthographicFront"/>
       <a:lightRig rig="threePt" dir="t"/>
     </dgm:scene3d>
+    <dgm:sp3d/>
     <dgm:txPr/>
     <dgm:style>
       <a:lnRef idx="2">
@@ -2467,6 +2340,7 @@
       <a:camera prst="orthographicFront"/>
       <a:lightRig rig="threePt" dir="t"/>
     </dgm:scene3d>
+    <dgm:sp3d/>
     <dgm:txPr/>
     <dgm:style>
       <a:lnRef idx="2">
@@ -2486,6 +2360,7 @@
       <a:camera prst="orthographicFront"/>
       <a:lightRig rig="threePt" dir="t"/>
     </dgm:scene3d>
+    <dgm:sp3d/>
     <dgm:txPr/>
     <dgm:style>
       <a:lnRef idx="2">
@@ -2505,6 +2380,7 @@
       <a:camera prst="orthographicFront"/>
       <a:lightRig rig="threePt" dir="t"/>
     </dgm:scene3d>
+    <dgm:sp3d/>
     <dgm:txPr/>
     <dgm:style>
       <a:lnRef idx="2">
@@ -2524,6 +2400,7 @@
       <a:camera prst="orthographicFront"/>
       <a:lightRig rig="threePt" dir="t"/>
     </dgm:scene3d>
+    <dgm:sp3d/>
     <dgm:txPr/>
     <dgm:style>
       <a:lnRef idx="2">
@@ -2543,6 +2420,7 @@
       <a:camera prst="orthographicFront"/>
       <a:lightRig rig="threePt" dir="t"/>
     </dgm:scene3d>
+    <dgm:sp3d/>
     <dgm:txPr/>
     <dgm:style>
       <a:lnRef idx="2">
@@ -2562,6 +2440,7 @@
       <a:camera prst="orthographicFront"/>
       <a:lightRig rig="threePt" dir="t"/>
     </dgm:scene3d>
+    <dgm:sp3d/>
     <dgm:txPr/>
     <dgm:style>
       <a:lnRef idx="2">
@@ -2581,6 +2460,7 @@
       <a:camera prst="orthographicFront"/>
       <a:lightRig rig="threePt" dir="t"/>
     </dgm:scene3d>
+    <dgm:sp3d/>
     <dgm:txPr/>
     <dgm:style>
       <a:lnRef idx="0">
@@ -2602,6 +2482,7 @@
       <a:camera prst="orthographicFront"/>
       <a:lightRig rig="threePt" dir="t"/>
     </dgm:scene3d>
+    <dgm:sp3d/>
     <dgm:txPr/>
     <dgm:style>
       <a:lnRef idx="2">
@@ -2623,6 +2504,7 @@
       <a:camera prst="orthographicFront"/>
       <a:lightRig rig="threePt" dir="t"/>
     </dgm:scene3d>
+    <dgm:sp3d/>
     <dgm:txPr/>
     <dgm:style>
       <a:lnRef idx="2">
@@ -2644,6 +2526,7 @@
       <a:camera prst="orthographicFront"/>
       <a:lightRig rig="threePt" dir="t"/>
     </dgm:scene3d>
+    <dgm:sp3d/>
     <dgm:txPr/>
     <dgm:style>
       <a:lnRef idx="2">
@@ -2665,6 +2548,7 @@
       <a:camera prst="orthographicFront"/>
       <a:lightRig rig="threePt" dir="t"/>
     </dgm:scene3d>
+    <dgm:sp3d/>
     <dgm:txPr/>
     <dgm:style>
       <a:lnRef idx="2">
@@ -2686,6 +2570,7 @@
       <a:camera prst="orthographicFront"/>
       <a:lightRig rig="threePt" dir="t"/>
     </dgm:scene3d>
+    <dgm:sp3d/>
     <dgm:txPr/>
     <dgm:style>
       <a:lnRef idx="2">
@@ -2707,6 +2592,7 @@
       <a:camera prst="orthographicFront"/>
       <a:lightRig rig="threePt" dir="t"/>
     </dgm:scene3d>
+    <dgm:sp3d/>
     <dgm:txPr/>
     <dgm:style>
       <a:lnRef idx="2">
@@ -2728,6 +2614,7 @@
       <a:camera prst="orthographicFront"/>
       <a:lightRig rig="threePt" dir="t"/>
     </dgm:scene3d>
+    <dgm:sp3d/>
     <dgm:txPr/>
     <dgm:style>
       <a:lnRef idx="2">
@@ -2747,6 +2634,7 @@
       <a:camera prst="orthographicFront"/>
       <a:lightRig rig="threePt" dir="t"/>
     </dgm:scene3d>
+    <dgm:sp3d/>
     <dgm:txPr/>
     <dgm:style>
       <a:lnRef idx="2">
@@ -2766,6 +2654,7 @@
       <a:camera prst="orthographicFront"/>
       <a:lightRig rig="threePt" dir="t"/>
     </dgm:scene3d>
+    <dgm:sp3d/>
     <dgm:txPr/>
     <dgm:style>
       <a:lnRef idx="2">
@@ -2785,6 +2674,7 @@
       <a:camera prst="orthographicFront"/>
       <a:lightRig rig="threePt" dir="t"/>
     </dgm:scene3d>
+    <dgm:sp3d/>
     <dgm:txPr/>
     <dgm:style>
       <a:lnRef idx="2">
@@ -2804,6 +2694,7 @@
       <a:camera prst="orthographicFront"/>
       <a:lightRig rig="threePt" dir="t"/>
     </dgm:scene3d>
+    <dgm:sp3d/>
     <dgm:txPr/>
     <dgm:style>
       <a:lnRef idx="2">
@@ -2825,6 +2716,7 @@
       <a:camera prst="orthographicFront"/>
       <a:lightRig rig="threePt" dir="t"/>
     </dgm:scene3d>
+    <dgm:sp3d/>
     <dgm:txPr/>
     <dgm:style>
       <a:lnRef idx="2">
@@ -2846,6 +2738,7 @@
       <a:camera prst="orthographicFront"/>
       <a:lightRig rig="threePt" dir="t"/>
     </dgm:scene3d>
+    <dgm:sp3d/>
     <dgm:txPr/>
     <dgm:style>
       <a:lnRef idx="2">
@@ -2867,6 +2760,7 @@
       <a:camera prst="orthographicFront"/>
       <a:lightRig rig="threePt" dir="t"/>
     </dgm:scene3d>
+    <dgm:sp3d/>
     <dgm:txPr/>
     <dgm:style>
       <a:lnRef idx="2">
@@ -2888,6 +2782,7 @@
       <a:camera prst="orthographicFront"/>
       <a:lightRig rig="threePt" dir="t"/>
     </dgm:scene3d>
+    <dgm:sp3d/>
     <dgm:txPr/>
     <dgm:style>
       <a:lnRef idx="0">
@@ -2907,6 +2802,7 @@
       <a:camera prst="orthographicFront"/>
       <a:lightRig rig="threePt" dir="t"/>
     </dgm:scene3d>
+    <dgm:sp3d/>
     <dgm:txPr/>
     <dgm:style>
       <a:lnRef idx="1">
@@ -2926,6 +2822,7 @@
       <a:camera prst="orthographicFront"/>
       <a:lightRig rig="threePt" dir="t"/>
     </dgm:scene3d>
+    <dgm:sp3d/>
     <dgm:txPr/>
     <dgm:style>
       <a:lnRef idx="0">
@@ -2947,6 +2844,7 @@
       <a:camera prst="orthographicFront"/>
       <a:lightRig rig="threePt" dir="t"/>
     </dgm:scene3d>
+    <dgm:sp3d/>
     <dgm:txPr/>
     <dgm:style>
       <a:lnRef idx="2">
@@ -2966,6 +2864,7 @@
       <a:camera prst="orthographicFront"/>
       <a:lightRig rig="threePt" dir="t"/>
     </dgm:scene3d>
+    <dgm:sp3d/>
     <dgm:txPr/>
     <dgm:style>
       <a:lnRef idx="2">
@@ -2985,6 +2884,7 @@
       <a:camera prst="orthographicFront"/>
       <a:lightRig rig="threePt" dir="t"/>
     </dgm:scene3d>
+    <dgm:sp3d/>
     <dgm:txPr/>
     <dgm:style>
       <a:lnRef idx="2">
@@ -3004,6 +2904,7 @@
       <a:camera prst="orthographicFront"/>
       <a:lightRig rig="threePt" dir="t"/>
     </dgm:scene3d>
+    <dgm:sp3d/>
     <dgm:txPr/>
     <dgm:style>
       <a:lnRef idx="1">
@@ -3023,6 +2924,7 @@
       <a:camera prst="orthographicFront"/>
       <a:lightRig rig="threePt" dir="t"/>
     </dgm:scene3d>
+    <dgm:sp3d/>
     <dgm:txPr/>
     <dgm:style>
       <a:lnRef idx="0">
@@ -3042,6 +2944,7 @@
       <a:camera prst="orthographicFront"/>
       <a:lightRig rig="threePt" dir="t"/>
     </dgm:scene3d>
+    <dgm:sp3d/>
     <dgm:txPr/>
     <dgm:style>
       <a:lnRef idx="2">
@@ -3143,6 +3046,7 @@
           <a:p>
             <a:fld id="{AD1F36F0-DB60-4567-B6EB-E52A0F2F7D2D}" type="datetimeFigureOut">
               <a:rPr lang="en-US" smtClean="0"/>
+              <a:t>6/9/2026</a:t>
             </a:fld>
             <a:endParaRPr lang="en-US"/>
           </a:p>
@@ -3209,7 +3113,6 @@
               <a:rPr lang="en-US"/>
               <a:t>Click to edit Master text styles</a:t>
             </a:r>
-            <a:endParaRPr lang="en-US"/>
           </a:p>
           <a:p>
             <a:pPr lvl="1"/>
@@ -3217,7 +3120,6 @@
               <a:rPr lang="en-US"/>
               <a:t>Second level</a:t>
             </a:r>
-            <a:endParaRPr lang="en-US"/>
           </a:p>
           <a:p>
             <a:pPr lvl="2"/>
@@ -3225,7 +3127,6 @@
               <a:rPr lang="en-US"/>
               <a:t>Third level</a:t>
             </a:r>
-            <a:endParaRPr lang="en-US"/>
           </a:p>
           <a:p>
             <a:pPr lvl="3"/>
@@ -3233,7 +3134,6 @@
               <a:rPr lang="en-US"/>
               <a:t>Fourth level</a:t>
             </a:r>
-            <a:endParaRPr lang="en-US"/>
           </a:p>
           <a:p>
             <a:pPr lvl="4"/>
@@ -3241,7 +3141,6 @@
               <a:rPr lang="en-US"/>
               <a:t>Fifth level</a:t>
             </a:r>
-            <a:endParaRPr lang="en-US"/>
           </a:p>
         </p:txBody>
       </p:sp>
@@ -3305,6 +3204,7 @@
           <a:p>
             <a:fld id="{DB7D8131-CA0A-4EF1-A472-A6FDB2755101}" type="slidenum">
               <a:rPr lang="en-US" smtClean="0"/>
+              <a:t>‹#›</a:t>
             </a:fld>
             <a:endParaRPr lang="en-US"/>
           </a:p>
@@ -3478,6 +3378,7 @@
           <a:p>
             <a:fld id="{9BD2C428-55DE-42C6-851D-CB4CC7C211F9}" type="slidenum">
               <a:rPr lang="en-US" smtClean="0"/>
+              <a:t>3</a:t>
             </a:fld>
             <a:endParaRPr lang="en-US"/>
           </a:p>
@@ -3562,6 +3463,7 @@
           <a:p>
             <a:fld id="{7CE77197-739D-4B26-AF33-8D06BC2CEE70}" type="slidenum">
               <a:rPr lang="en-US" smtClean="0"/>
+              <a:t>38</a:t>
             </a:fld>
             <a:endParaRPr lang="en-US"/>
           </a:p>
@@ -3653,6 +3555,7 @@
           <a:p>
             <a:fld id="{DB7D8131-CA0A-4EF1-A472-A6FDB2755101}" type="slidenum">
               <a:rPr lang="en-US" smtClean="0"/>
+              <a:t>10</a:t>
             </a:fld>
             <a:endParaRPr lang="en-US"/>
           </a:p>
@@ -3752,6 +3655,7 @@
           <a:p>
             <a:fld id="{DB7D8131-CA0A-4EF1-A472-A6FDB2755101}" type="slidenum">
               <a:rPr lang="en-US" smtClean="0"/>
+              <a:t>11</a:t>
             </a:fld>
             <a:endParaRPr lang="en-US"/>
           </a:p>
@@ -3813,7 +3717,6 @@
               <a:rPr lang="zh-CN" altLang="en-US" dirty="0"/>
               <a:t>如果这一重要功能的设计者在做需求分析的时候就模仿用户，设计场景，实地演一次戏，很快 就能发现戏演不下去了。</a:t>
             </a:r>
-            <a:endParaRPr lang="zh-CN" altLang="en-US" dirty="0"/>
           </a:p>
           <a:p>
             <a:endParaRPr lang="en-US" dirty="0"/>
@@ -3837,6 +3740,7 @@
           <a:p>
             <a:fld id="{F35C7EE1-DFFA-4275-BC15-03F63508087A}" type="slidenum">
               <a:rPr lang="en-US" smtClean="0"/>
+              <a:t>18</a:t>
             </a:fld>
             <a:endParaRPr lang="en-US"/>
           </a:p>
@@ -3919,6 +3823,7 @@
           <a:p>
             <a:fld id="{F35C7EE1-DFFA-4275-BC15-03F63508087A}" type="slidenum">
               <a:rPr lang="en-US" smtClean="0"/>
+              <a:t>19</a:t>
             </a:fld>
             <a:endParaRPr lang="en-US"/>
           </a:p>
@@ -3997,6 +3902,7 @@
           <a:p>
             <a:fld id="{F35C7EE1-DFFA-4275-BC15-03F63508087A}" type="slidenum">
               <a:rPr lang="en-US" smtClean="0"/>
+              <a:t>21</a:t>
             </a:fld>
             <a:endParaRPr lang="en-US"/>
           </a:p>
@@ -4058,7 +3964,6 @@
               <a:rPr lang="en-US" dirty="0"/>
               <a:t>https://speckyboy.com/successful-minimum-viable-products/   </a:t>
             </a:r>
-            <a:endParaRPr lang="en-US" dirty="0"/>
           </a:p>
         </p:txBody>
       </p:sp>
@@ -4079,6 +3984,7 @@
           <a:p>
             <a:fld id="{F35C7EE1-DFFA-4275-BC15-03F63508087A}" type="slidenum">
               <a:rPr lang="en-US" smtClean="0"/>
+              <a:t>24</a:t>
             </a:fld>
             <a:endParaRPr lang="en-US"/>
           </a:p>
@@ -4172,6 +4078,7 @@
           <a:p>
             <a:fld id="{CE8CEAE1-7D0B-4C6D-B6B2-9BA18BD90F17}" type="slidenum">
               <a:rPr lang="en-US" smtClean="0"/>
+              <a:t>27</a:t>
             </a:fld>
             <a:endParaRPr lang="en-US"/>
           </a:p>
@@ -4250,6 +4157,7 @@
           <a:p>
             <a:fld id="{DB7D8131-CA0A-4EF1-A472-A6FDB2755101}" type="slidenum">
               <a:rPr lang="en-US" smtClean="0"/>
+              <a:t>29</a:t>
             </a:fld>
             <a:endParaRPr lang="en-US"/>
           </a:p>
@@ -4459,6 +4367,7 @@
           <a:p>
             <a:fld id="{48A87A34-81AB-432B-8DAE-1953F412C126}" type="datetimeFigureOut">
               <a:rPr lang="en-US" smtClean="0"/>
+              <a:t>6/9/2026</a:t>
             </a:fld>
             <a:endParaRPr lang="en-US" dirty="0"/>
           </a:p>
@@ -4500,6 +4409,7 @@
           <a:p>
             <a:fld id="{6D22F896-40B5-4ADD-8801-0D06FADFA095}" type="slidenum">
               <a:rPr lang="en-US" smtClean="0"/>
+              <a:t>‹#›</a:t>
             </a:fld>
             <a:endParaRPr lang="en-US" dirty="0"/>
           </a:p>
@@ -4713,7 +4623,6 @@
               <a:rPr lang="en-US"/>
               <a:t>Edit Master text styles</a:t>
             </a:r>
-            <a:endParaRPr lang="en-US"/>
           </a:p>
         </p:txBody>
       </p:sp>
@@ -4734,6 +4643,7 @@
           <a:p>
             <a:fld id="{48A87A34-81AB-432B-8DAE-1953F412C126}" type="datetimeFigureOut">
               <a:rPr lang="en-US" smtClean="0"/>
+              <a:t>6/9/2026</a:t>
             </a:fld>
             <a:endParaRPr lang="en-US" dirty="0"/>
           </a:p>
@@ -4775,6 +4685,7 @@
           <a:p>
             <a:fld id="{6D22F896-40B5-4ADD-8801-0D06FADFA095}" type="slidenum">
               <a:rPr lang="en-US" smtClean="0"/>
+              <a:t>‹#›</a:t>
             </a:fld>
             <a:endParaRPr lang="en-US" dirty="0"/>
           </a:p>
@@ -4899,7 +4810,6 @@
               <a:rPr lang="en-US"/>
               <a:t>Edit Master text styles</a:t>
             </a:r>
-            <a:endParaRPr lang="en-US"/>
           </a:p>
         </p:txBody>
       </p:sp>
@@ -4920,6 +4830,7 @@
           <a:p>
             <a:fld id="{48A87A34-81AB-432B-8DAE-1953F412C126}" type="datetimeFigureOut">
               <a:rPr lang="en-US" smtClean="0"/>
+              <a:t>6/9/2026</a:t>
             </a:fld>
             <a:endParaRPr lang="en-US" dirty="0"/>
           </a:p>
@@ -4961,6 +4872,7 @@
           <a:p>
             <a:fld id="{6D22F896-40B5-4ADD-8801-0D06FADFA095}" type="slidenum">
               <a:rPr lang="en-US" smtClean="0"/>
+              <a:t>‹#›</a:t>
             </a:fld>
             <a:endParaRPr lang="en-US" dirty="0"/>
           </a:p>
@@ -5087,7 +4999,6 @@
               <a:rPr lang="en-US"/>
               <a:t>Edit Master text styles</a:t>
             </a:r>
-            <a:endParaRPr lang="en-US"/>
           </a:p>
         </p:txBody>
       </p:sp>
@@ -5155,7 +5066,6 @@
               <a:rPr lang="en-US"/>
               <a:t>Edit Master text styles</a:t>
             </a:r>
-            <a:endParaRPr lang="en-US"/>
           </a:p>
         </p:txBody>
       </p:sp>
@@ -5176,6 +5086,7 @@
           <a:p>
             <a:fld id="{48A87A34-81AB-432B-8DAE-1953F412C126}" type="datetimeFigureOut">
               <a:rPr lang="en-US" smtClean="0"/>
+              <a:t>6/9/2026</a:t>
             </a:fld>
             <a:endParaRPr lang="en-US" dirty="0"/>
           </a:p>
@@ -5217,6 +5128,7 @@
           <a:p>
             <a:fld id="{6D22F896-40B5-4ADD-8801-0D06FADFA095}" type="slidenum">
               <a:rPr lang="en-US" smtClean="0"/>
+              <a:t>‹#›</a:t>
             </a:fld>
             <a:endParaRPr lang="en-US" dirty="0"/>
           </a:p>
@@ -5335,12 +5247,6 @@
               </a:rPr>
               <a:t>“</a:t>
             </a:r>
-            <a:endParaRPr lang="en-US" sz="8000" dirty="0">
-              <a:solidFill>
-                <a:schemeClr val="tx1"/>
-              </a:solidFill>
-              <a:effectLst/>
-            </a:endParaRPr>
           </a:p>
         </p:txBody>
       </p:sp>
@@ -5457,12 +5363,6 @@
               </a:rPr>
               <a:t>”</a:t>
             </a:r>
-            <a:endParaRPr lang="en-US" sz="8000" dirty="0">
-              <a:solidFill>
-                <a:schemeClr val="tx1"/>
-              </a:solidFill>
-              <a:effectLst/>
-            </a:endParaRPr>
           </a:p>
         </p:txBody>
       </p:sp>
@@ -5587,7 +5487,6 @@
               <a:rPr lang="en-US"/>
               <a:t>Edit Master text styles</a:t>
             </a:r>
-            <a:endParaRPr lang="en-US"/>
           </a:p>
         </p:txBody>
       </p:sp>
@@ -5608,6 +5507,7 @@
           <a:p>
             <a:fld id="{48A87A34-81AB-432B-8DAE-1953F412C126}" type="datetimeFigureOut">
               <a:rPr lang="en-US" smtClean="0"/>
+              <a:t>6/9/2026</a:t>
             </a:fld>
             <a:endParaRPr lang="en-US" dirty="0"/>
           </a:p>
@@ -5649,6 +5549,7 @@
           <a:p>
             <a:fld id="{6D22F896-40B5-4ADD-8801-0D06FADFA095}" type="slidenum">
               <a:rPr lang="en-US" smtClean="0"/>
+              <a:t>‹#›</a:t>
             </a:fld>
             <a:endParaRPr lang="en-US" dirty="0"/>
           </a:p>
@@ -5798,7 +5699,6 @@
               <a:rPr lang="en-US"/>
               <a:t>Edit Master text styles</a:t>
             </a:r>
-            <a:endParaRPr lang="en-US"/>
           </a:p>
         </p:txBody>
       </p:sp>
@@ -5866,7 +5766,6 @@
               <a:rPr lang="en-US"/>
               <a:t>Edit Master text styles</a:t>
             </a:r>
-            <a:endParaRPr lang="en-US"/>
           </a:p>
         </p:txBody>
       </p:sp>
@@ -5931,7 +5830,6 @@
               <a:rPr lang="en-US"/>
               <a:t>Edit Master text styles</a:t>
             </a:r>
-            <a:endParaRPr lang="en-US"/>
           </a:p>
         </p:txBody>
       </p:sp>
@@ -5999,7 +5897,6 @@
               <a:rPr lang="en-US"/>
               <a:t>Edit Master text styles</a:t>
             </a:r>
-            <a:endParaRPr lang="en-US"/>
           </a:p>
         </p:txBody>
       </p:sp>
@@ -6064,7 +5961,6 @@
               <a:rPr lang="en-US"/>
               <a:t>Edit Master text styles</a:t>
             </a:r>
-            <a:endParaRPr lang="en-US"/>
           </a:p>
         </p:txBody>
       </p:sp>
@@ -6132,7 +6028,6 @@
               <a:rPr lang="en-US"/>
               <a:t>Edit Master text styles</a:t>
             </a:r>
-            <a:endParaRPr lang="en-US"/>
           </a:p>
         </p:txBody>
       </p:sp>
@@ -6153,6 +6048,7 @@
           <a:p>
             <a:fld id="{48A87A34-81AB-432B-8DAE-1953F412C126}" type="datetimeFigureOut">
               <a:rPr lang="en-US" smtClean="0"/>
+              <a:t>6/9/2026</a:t>
             </a:fld>
             <a:endParaRPr lang="en-US" dirty="0"/>
           </a:p>
@@ -6194,6 +6090,7 @@
           <a:p>
             <a:fld id="{6D22F896-40B5-4ADD-8801-0D06FADFA095}" type="slidenum">
               <a:rPr lang="en-US" smtClean="0"/>
+              <a:t>‹#›</a:t>
             </a:fld>
             <a:endParaRPr lang="en-US" dirty="0"/>
           </a:p>
@@ -6339,7 +6236,6 @@
               <a:rPr lang="en-US"/>
               <a:t>Edit Master text styles</a:t>
             </a:r>
-            <a:endParaRPr lang="en-US"/>
           </a:p>
         </p:txBody>
       </p:sp>
@@ -6486,7 +6382,6 @@
               <a:rPr lang="en-US"/>
               <a:t>Edit Master text styles</a:t>
             </a:r>
-            <a:endParaRPr lang="en-US"/>
           </a:p>
         </p:txBody>
       </p:sp>
@@ -6577,7 +6472,6 @@
               <a:rPr lang="en-US"/>
               <a:t>Edit Master text styles</a:t>
             </a:r>
-            <a:endParaRPr lang="en-US"/>
           </a:p>
         </p:txBody>
       </p:sp>
@@ -6724,7 +6618,6 @@
               <a:rPr lang="en-US"/>
               <a:t>Edit Master text styles</a:t>
             </a:r>
-            <a:endParaRPr lang="en-US"/>
           </a:p>
         </p:txBody>
       </p:sp>
@@ -6815,7 +6708,6 @@
               <a:rPr lang="en-US"/>
               <a:t>Edit Master text styles</a:t>
             </a:r>
-            <a:endParaRPr lang="en-US"/>
           </a:p>
         </p:txBody>
       </p:sp>
@@ -6962,7 +6854,6 @@
               <a:rPr lang="en-US"/>
               <a:t>Edit Master text styles</a:t>
             </a:r>
-            <a:endParaRPr lang="en-US"/>
           </a:p>
         </p:txBody>
       </p:sp>
@@ -6983,6 +6874,7 @@
           <a:p>
             <a:fld id="{48A87A34-81AB-432B-8DAE-1953F412C126}" type="datetimeFigureOut">
               <a:rPr lang="en-US" smtClean="0"/>
+              <a:t>6/9/2026</a:t>
             </a:fld>
             <a:endParaRPr lang="en-US" dirty="0"/>
           </a:p>
@@ -7024,6 +6916,7 @@
           <a:p>
             <a:fld id="{6D22F896-40B5-4ADD-8801-0D06FADFA095}" type="slidenum">
               <a:rPr lang="en-US" smtClean="0"/>
+              <a:t>‹#›</a:t>
             </a:fld>
             <a:endParaRPr lang="en-US" dirty="0"/>
           </a:p>
@@ -7097,7 +6990,6 @@
               <a:rPr lang="en-US"/>
               <a:t>Edit Master text styles</a:t>
             </a:r>
-            <a:endParaRPr lang="en-US"/>
           </a:p>
           <a:p>
             <a:pPr lvl="1"/>
@@ -7105,7 +6997,6 @@
               <a:rPr lang="en-US"/>
               <a:t>Second level</a:t>
             </a:r>
-            <a:endParaRPr lang="en-US"/>
           </a:p>
           <a:p>
             <a:pPr lvl="2"/>
@@ -7113,7 +7004,6 @@
               <a:rPr lang="en-US"/>
               <a:t>Third level</a:t>
             </a:r>
-            <a:endParaRPr lang="en-US"/>
           </a:p>
           <a:p>
             <a:pPr lvl="3"/>
@@ -7121,7 +7011,6 @@
               <a:rPr lang="en-US"/>
               <a:t>Fourth level</a:t>
             </a:r>
-            <a:endParaRPr lang="en-US"/>
           </a:p>
           <a:p>
             <a:pPr lvl="4"/>
@@ -7150,6 +7039,7 @@
           <a:p>
             <a:fld id="{48A87A34-81AB-432B-8DAE-1953F412C126}" type="datetimeFigureOut">
               <a:rPr lang="en-US" smtClean="0"/>
+              <a:t>6/9/2026</a:t>
             </a:fld>
             <a:endParaRPr lang="en-US" dirty="0"/>
           </a:p>
@@ -7191,6 +7081,7 @@
           <a:p>
             <a:fld id="{6D22F896-40B5-4ADD-8801-0D06FADFA095}" type="slidenum">
               <a:rPr lang="en-US" smtClean="0"/>
+              <a:t>‹#›</a:t>
             </a:fld>
             <a:endParaRPr lang="en-US" dirty="0"/>
           </a:p>
@@ -7274,7 +7165,6 @@
               <a:rPr lang="en-US"/>
               <a:t>Edit Master text styles</a:t>
             </a:r>
-            <a:endParaRPr lang="en-US"/>
           </a:p>
           <a:p>
             <a:pPr lvl="1"/>
@@ -7282,7 +7172,6 @@
               <a:rPr lang="en-US"/>
               <a:t>Second level</a:t>
             </a:r>
-            <a:endParaRPr lang="en-US"/>
           </a:p>
           <a:p>
             <a:pPr lvl="2"/>
@@ -7290,7 +7179,6 @@
               <a:rPr lang="en-US"/>
               <a:t>Third level</a:t>
             </a:r>
-            <a:endParaRPr lang="en-US"/>
           </a:p>
           <a:p>
             <a:pPr lvl="3"/>
@@ -7298,7 +7186,6 @@
               <a:rPr lang="en-US"/>
               <a:t>Fourth level</a:t>
             </a:r>
-            <a:endParaRPr lang="en-US"/>
           </a:p>
           <a:p>
             <a:pPr lvl="4"/>
@@ -7327,6 +7214,7 @@
           <a:p>
             <a:fld id="{48A87A34-81AB-432B-8DAE-1953F412C126}" type="datetimeFigureOut">
               <a:rPr lang="en-US" smtClean="0"/>
+              <a:t>6/9/2026</a:t>
             </a:fld>
             <a:endParaRPr lang="en-US" dirty="0"/>
           </a:p>
@@ -7368,6 +7256,7 @@
           <a:p>
             <a:fld id="{6D22F896-40B5-4ADD-8801-0D06FADFA095}" type="slidenum">
               <a:rPr lang="en-US" smtClean="0"/>
+              <a:t>‹#›</a:t>
             </a:fld>
             <a:endParaRPr lang="en-US" dirty="0"/>
           </a:p>
@@ -7441,7 +7330,6 @@
               <a:rPr lang="en-US"/>
               <a:t>Edit Master text styles</a:t>
             </a:r>
-            <a:endParaRPr lang="en-US"/>
           </a:p>
           <a:p>
             <a:pPr lvl="1"/>
@@ -7449,7 +7337,6 @@
               <a:rPr lang="en-US"/>
               <a:t>Second level</a:t>
             </a:r>
-            <a:endParaRPr lang="en-US"/>
           </a:p>
           <a:p>
             <a:pPr lvl="2"/>
@@ -7457,7 +7344,6 @@
               <a:rPr lang="en-US"/>
               <a:t>Third level</a:t>
             </a:r>
-            <a:endParaRPr lang="en-US"/>
           </a:p>
           <a:p>
             <a:pPr lvl="3"/>
@@ -7465,7 +7351,6 @@
               <a:rPr lang="en-US"/>
               <a:t>Fourth level</a:t>
             </a:r>
-            <a:endParaRPr lang="en-US"/>
           </a:p>
           <a:p>
             <a:pPr lvl="4"/>
@@ -7494,6 +7379,7 @@
           <a:p>
             <a:fld id="{48A87A34-81AB-432B-8DAE-1953F412C126}" type="datetimeFigureOut">
               <a:rPr lang="en-US" smtClean="0"/>
+              <a:t>6/9/2026</a:t>
             </a:fld>
             <a:endParaRPr lang="en-US" dirty="0"/>
           </a:p>
@@ -7535,6 +7421,7 @@
           <a:p>
             <a:fld id="{6D22F896-40B5-4ADD-8801-0D06FADFA095}" type="slidenum">
               <a:rPr lang="en-US" smtClean="0"/>
+              <a:t>‹#›</a:t>
             </a:fld>
             <a:endParaRPr lang="en-US" dirty="0"/>
           </a:p>
@@ -7744,6 +7631,7 @@
           <a:p>
             <a:fld id="{48A87A34-81AB-432B-8DAE-1953F412C126}" type="datetimeFigureOut">
               <a:rPr lang="en-US" smtClean="0"/>
+              <a:t>6/9/2026</a:t>
             </a:fld>
             <a:endParaRPr lang="en-US" dirty="0"/>
           </a:p>
@@ -7785,6 +7673,7 @@
           <a:p>
             <a:fld id="{6D22F896-40B5-4ADD-8801-0D06FADFA095}" type="slidenum">
               <a:rPr lang="en-US" smtClean="0"/>
+              <a:t>‹#›</a:t>
             </a:fld>
             <a:endParaRPr lang="en-US" dirty="0"/>
           </a:p>
@@ -7863,7 +7752,6 @@
               <a:rPr lang="en-US"/>
               <a:t>Edit Master text styles</a:t>
             </a:r>
-            <a:endParaRPr lang="en-US"/>
           </a:p>
           <a:p>
             <a:pPr lvl="1"/>
@@ -7871,7 +7759,6 @@
               <a:rPr lang="en-US"/>
               <a:t>Second level</a:t>
             </a:r>
-            <a:endParaRPr lang="en-US"/>
           </a:p>
           <a:p>
             <a:pPr lvl="2"/>
@@ -7879,7 +7766,6 @@
               <a:rPr lang="en-US"/>
               <a:t>Third level</a:t>
             </a:r>
-            <a:endParaRPr lang="en-US"/>
           </a:p>
           <a:p>
             <a:pPr lvl="3"/>
@@ -7887,7 +7773,6 @@
               <a:rPr lang="en-US"/>
               <a:t>Fourth level</a:t>
             </a:r>
-            <a:endParaRPr lang="en-US"/>
           </a:p>
           <a:p>
             <a:pPr lvl="4"/>
@@ -7924,7 +7809,6 @@
               <a:rPr lang="en-US"/>
               <a:t>Edit Master text styles</a:t>
             </a:r>
-            <a:endParaRPr lang="en-US"/>
           </a:p>
           <a:p>
             <a:pPr lvl="1"/>
@@ -7932,7 +7816,6 @@
               <a:rPr lang="en-US"/>
               <a:t>Second level</a:t>
             </a:r>
-            <a:endParaRPr lang="en-US"/>
           </a:p>
           <a:p>
             <a:pPr lvl="2"/>
@@ -7940,7 +7823,6 @@
               <a:rPr lang="en-US"/>
               <a:t>Third level</a:t>
             </a:r>
-            <a:endParaRPr lang="en-US"/>
           </a:p>
           <a:p>
             <a:pPr lvl="3"/>
@@ -7948,7 +7830,6 @@
               <a:rPr lang="en-US"/>
               <a:t>Fourth level</a:t>
             </a:r>
-            <a:endParaRPr lang="en-US"/>
           </a:p>
           <a:p>
             <a:pPr lvl="4"/>
@@ -7977,6 +7858,7 @@
           <a:p>
             <a:fld id="{48A87A34-81AB-432B-8DAE-1953F412C126}" type="datetimeFigureOut">
               <a:rPr lang="en-US" smtClean="0"/>
+              <a:t>6/9/2026</a:t>
             </a:fld>
             <a:endParaRPr lang="en-US" dirty="0"/>
           </a:p>
@@ -8018,6 +7900,7 @@
           <a:p>
             <a:fld id="{6D22F896-40B5-4ADD-8801-0D06FADFA095}" type="slidenum">
               <a:rPr lang="en-US" smtClean="0"/>
+              <a:t>‹#›</a:t>
             </a:fld>
             <a:endParaRPr lang="en-US" dirty="0"/>
           </a:p>
@@ -8165,7 +8048,6 @@
               <a:rPr lang="en-US"/>
               <a:t>Edit Master text styles</a:t>
             </a:r>
-            <a:endParaRPr lang="en-US"/>
           </a:p>
         </p:txBody>
       </p:sp>
@@ -8194,7 +8076,6 @@
               <a:rPr lang="en-US"/>
               <a:t>Edit Master text styles</a:t>
             </a:r>
-            <a:endParaRPr lang="en-US"/>
           </a:p>
           <a:p>
             <a:pPr lvl="1"/>
@@ -8202,7 +8083,6 @@
               <a:rPr lang="en-US"/>
               <a:t>Second level</a:t>
             </a:r>
-            <a:endParaRPr lang="en-US"/>
           </a:p>
           <a:p>
             <a:pPr lvl="2"/>
@@ -8210,7 +8090,6 @@
               <a:rPr lang="en-US"/>
               <a:t>Third level</a:t>
             </a:r>
-            <a:endParaRPr lang="en-US"/>
           </a:p>
           <a:p>
             <a:pPr lvl="3"/>
@@ -8218,7 +8097,6 @@
               <a:rPr lang="en-US"/>
               <a:t>Fourth level</a:t>
             </a:r>
-            <a:endParaRPr lang="en-US"/>
           </a:p>
           <a:p>
             <a:pPr lvl="4"/>
@@ -8291,7 +8169,6 @@
               <a:rPr lang="en-US"/>
               <a:t>Edit Master text styles</a:t>
             </a:r>
-            <a:endParaRPr lang="en-US"/>
           </a:p>
         </p:txBody>
       </p:sp>
@@ -8320,7 +8197,6 @@
               <a:rPr lang="en-US"/>
               <a:t>Edit Master text styles</a:t>
             </a:r>
-            <a:endParaRPr lang="en-US"/>
           </a:p>
           <a:p>
             <a:pPr lvl="1"/>
@@ -8328,7 +8204,6 @@
               <a:rPr lang="en-US"/>
               <a:t>Second level</a:t>
             </a:r>
-            <a:endParaRPr lang="en-US"/>
           </a:p>
           <a:p>
             <a:pPr lvl="2"/>
@@ -8336,7 +8211,6 @@
               <a:rPr lang="en-US"/>
               <a:t>Third level</a:t>
             </a:r>
-            <a:endParaRPr lang="en-US"/>
           </a:p>
           <a:p>
             <a:pPr lvl="3"/>
@@ -8344,7 +8218,6 @@
               <a:rPr lang="en-US"/>
               <a:t>Fourth level</a:t>
             </a:r>
-            <a:endParaRPr lang="en-US"/>
           </a:p>
           <a:p>
             <a:pPr lvl="4"/>
@@ -8373,6 +8246,7 @@
           <a:p>
             <a:fld id="{48A87A34-81AB-432B-8DAE-1953F412C126}" type="datetimeFigureOut">
               <a:rPr lang="en-US" smtClean="0"/>
+              <a:t>6/9/2026</a:t>
             </a:fld>
             <a:endParaRPr lang="en-US" dirty="0"/>
           </a:p>
@@ -8414,6 +8288,7 @@
           <a:p>
             <a:fld id="{6D22F896-40B5-4ADD-8801-0D06FADFA095}" type="slidenum">
               <a:rPr lang="en-US" smtClean="0"/>
+              <a:t>‹#›</a:t>
             </a:fld>
             <a:endParaRPr lang="en-US" dirty="0"/>
           </a:p>
@@ -8484,6 +8359,7 @@
           <a:p>
             <a:fld id="{48A87A34-81AB-432B-8DAE-1953F412C126}" type="datetimeFigureOut">
               <a:rPr lang="en-US" smtClean="0"/>
+              <a:t>6/9/2026</a:t>
             </a:fld>
             <a:endParaRPr lang="en-US" dirty="0"/>
           </a:p>
@@ -8525,6 +8401,7 @@
           <a:p>
             <a:fld id="{6D22F896-40B5-4ADD-8801-0D06FADFA095}" type="slidenum">
               <a:rPr lang="en-US" smtClean="0"/>
+              <a:t>‹#›</a:t>
             </a:fld>
             <a:endParaRPr lang="en-US" dirty="0"/>
           </a:p>
@@ -8572,6 +8449,7 @@
           <a:p>
             <a:fld id="{48A87A34-81AB-432B-8DAE-1953F412C126}" type="datetimeFigureOut">
               <a:rPr lang="en-US" smtClean="0"/>
+              <a:t>6/9/2026</a:t>
             </a:fld>
             <a:endParaRPr lang="en-US" dirty="0"/>
           </a:p>
@@ -8613,6 +8491,7 @@
           <a:p>
             <a:fld id="{6D22F896-40B5-4ADD-8801-0D06FADFA095}" type="slidenum">
               <a:rPr lang="en-US" smtClean="0"/>
+              <a:t>‹#›</a:t>
             </a:fld>
             <a:endParaRPr lang="en-US" dirty="0"/>
           </a:p>
@@ -8700,7 +8579,6 @@
               <a:rPr lang="en-US"/>
               <a:t>Edit Master text styles</a:t>
             </a:r>
-            <a:endParaRPr lang="en-US"/>
           </a:p>
           <a:p>
             <a:pPr lvl="1"/>
@@ -8708,7 +8586,6 @@
               <a:rPr lang="en-US"/>
               <a:t>Second level</a:t>
             </a:r>
-            <a:endParaRPr lang="en-US"/>
           </a:p>
           <a:p>
             <a:pPr lvl="2"/>
@@ -8716,7 +8593,6 @@
               <a:rPr lang="en-US"/>
               <a:t>Third level</a:t>
             </a:r>
-            <a:endParaRPr lang="en-US"/>
           </a:p>
           <a:p>
             <a:pPr lvl="3"/>
@@ -8724,7 +8600,6 @@
               <a:rPr lang="en-US"/>
               <a:t>Fourth level</a:t>
             </a:r>
-            <a:endParaRPr lang="en-US"/>
           </a:p>
           <a:p>
             <a:pPr lvl="4"/>
@@ -8822,7 +8697,6 @@
               <a:rPr lang="en-US"/>
               <a:t>Edit Master text styles</a:t>
             </a:r>
-            <a:endParaRPr lang="en-US"/>
           </a:p>
         </p:txBody>
       </p:sp>
@@ -8843,6 +8717,7 @@
           <a:p>
             <a:fld id="{48A87A34-81AB-432B-8DAE-1953F412C126}" type="datetimeFigureOut">
               <a:rPr lang="en-US" smtClean="0"/>
+              <a:t>6/9/2026</a:t>
             </a:fld>
             <a:endParaRPr lang="en-US" dirty="0"/>
           </a:p>
@@ -8884,6 +8759,7 @@
           <a:p>
             <a:fld id="{6D22F896-40B5-4ADD-8801-0D06FADFA095}" type="slidenum">
               <a:rPr lang="en-US" smtClean="0"/>
+              <a:t>‹#›</a:t>
             </a:fld>
             <a:endParaRPr lang="en-US" dirty="0"/>
           </a:p>
@@ -9097,7 +8973,6 @@
               <a:rPr lang="en-US"/>
               <a:t>Edit Master text styles</a:t>
             </a:r>
-            <a:endParaRPr lang="en-US"/>
           </a:p>
         </p:txBody>
       </p:sp>
@@ -9118,6 +8993,7 @@
           <a:p>
             <a:fld id="{48A87A34-81AB-432B-8DAE-1953F412C126}" type="datetimeFigureOut">
               <a:rPr lang="en-US" smtClean="0"/>
+              <a:t>6/9/2026</a:t>
             </a:fld>
             <a:endParaRPr lang="en-US" dirty="0"/>
           </a:p>
@@ -9159,6 +9035,7 @@
           <a:p>
             <a:fld id="{6D22F896-40B5-4ADD-8801-0D06FADFA095}" type="slidenum">
               <a:rPr lang="en-US" smtClean="0"/>
+              <a:t>‹#›</a:t>
             </a:fld>
             <a:endParaRPr lang="en-US" dirty="0"/>
           </a:p>
@@ -9178,7 +9055,7 @@
     <p:bg>
       <p:bgPr>
         <a:blipFill dpi="0" rotWithShape="1">
-          <a:blip r:embed="rId18">
+          <a:blip r:embed="rId19">
             <a:lum/>
           </a:blip>
           <a:srcRect/>
@@ -9266,7 +9143,6 @@
               <a:rPr lang="en-US"/>
               <a:t>Edit Master text styles</a:t>
             </a:r>
-            <a:endParaRPr lang="en-US"/>
           </a:p>
           <a:p>
             <a:pPr lvl="1"/>
@@ -9274,7 +9150,6 @@
               <a:rPr lang="en-US"/>
               <a:t>Second level</a:t>
             </a:r>
-            <a:endParaRPr lang="en-US"/>
           </a:p>
           <a:p>
             <a:pPr lvl="2"/>
@@ -9282,7 +9157,6 @@
               <a:rPr lang="en-US"/>
               <a:t>Third level</a:t>
             </a:r>
-            <a:endParaRPr lang="en-US"/>
           </a:p>
           <a:p>
             <a:pPr lvl="3"/>
@@ -9290,7 +9164,6 @@
               <a:rPr lang="en-US"/>
               <a:t>Fourth level</a:t>
             </a:r>
-            <a:endParaRPr lang="en-US"/>
           </a:p>
           <a:p>
             <a:pPr lvl="4"/>
@@ -9355,6 +9228,7 @@
           <a:p>
             <a:fld id="{48A87A34-81AB-432B-8DAE-1953F412C126}" type="datetimeFigureOut">
               <a:rPr lang="en-US" smtClean="0"/>
+              <a:t>6/9/2026</a:t>
             </a:fld>
             <a:endParaRPr lang="en-US" dirty="0"/>
           </a:p>
@@ -9468,6 +9342,7 @@
           <a:p>
             <a:fld id="{6D22F896-40B5-4ADD-8801-0D06FADFA095}" type="slidenum">
               <a:rPr lang="en-US" smtClean="0"/>
+              <a:t>‹#›</a:t>
             </a:fld>
             <a:endParaRPr lang="en-US" dirty="0"/>
           </a:p>
@@ -10040,7 +9915,6 @@
               <a:rPr lang="en-US" dirty="0"/>
               <a:t>Features have to work together, seamlessly</a:t>
             </a:r>
-            <a:endParaRPr lang="en-US" dirty="0"/>
           </a:p>
         </p:txBody>
       </p:sp>
@@ -10063,7 +9937,6 @@
               <a:rPr lang="en-US" dirty="0"/>
               <a:t>You work on a reader app, it has a dictionary,  you have 2 features:</a:t>
             </a:r>
-            <a:endParaRPr lang="en-US" dirty="0"/>
           </a:p>
           <a:p>
             <a:pPr lvl="1"/>
@@ -10071,7 +9944,6 @@
               <a:rPr lang="en-US" dirty="0"/>
               <a:t>Download the dictionary</a:t>
             </a:r>
-            <a:endParaRPr lang="en-US" dirty="0"/>
           </a:p>
           <a:p>
             <a:pPr lvl="1"/>
@@ -10079,7 +9951,6 @@
               <a:rPr lang="en-US" dirty="0"/>
               <a:t>When click a word, show the dictionary entry,  if no dictionary is present, </a:t>
             </a:r>
-            <a:endParaRPr lang="en-US" dirty="0"/>
           </a:p>
           <a:p>
             <a:pPr lvl="2"/>
@@ -10087,7 +9958,6 @@
               <a:rPr lang="en-US" dirty="0"/>
               <a:t>A) throw out an exception</a:t>
             </a:r>
-            <a:endParaRPr lang="en-US" dirty="0"/>
           </a:p>
           <a:p>
             <a:pPr lvl="2"/>
@@ -10103,7 +9973,6 @@
               <a:rPr lang="en-US" dirty="0"/>
               <a:t> to promote user to download</a:t>
             </a:r>
-            <a:endParaRPr lang="en-US" dirty="0"/>
           </a:p>
           <a:p>
             <a:pPr lvl="2"/>
@@ -10111,7 +9980,6 @@
               <a:rPr lang="en-US" dirty="0"/>
               <a:t>C) secretly download</a:t>
             </a:r>
-            <a:endParaRPr lang="en-US" dirty="0"/>
           </a:p>
           <a:p>
             <a:pPr lvl="2"/>
@@ -10119,7 +9987,6 @@
               <a:rPr lang="en-US" dirty="0"/>
               <a:t>D) cancelable download</a:t>
             </a:r>
-            <a:endParaRPr lang="en-US" dirty="0"/>
           </a:p>
         </p:txBody>
       </p:sp>
@@ -10167,7 +10034,6 @@
               <a:rPr lang="en-US" dirty="0"/>
               <a:t>Kindle for PC</a:t>
             </a:r>
-            <a:endParaRPr lang="en-US" dirty="0"/>
           </a:p>
         </p:txBody>
       </p:sp>
@@ -10199,7 +10065,7 @@
           <p:nvPr/>
         </p:nvPicPr>
         <p:blipFill>
-          <a:blip r:embed="rId1">
+          <a:blip r:embed="rId3">
             <a:extLst>
               <a:ext uri="{28A0092B-C50C-407E-A947-70E740481C1C}">
                 <a14:useLocalDpi xmlns:a14="http://schemas.microsoft.com/office/drawing/2010/main" val="0"/>
@@ -10298,7 +10164,6 @@
               <a:rPr lang="en-US" dirty="0"/>
               <a:t>Persona &amp; Scenario</a:t>
             </a:r>
-            <a:endParaRPr lang="en-US" dirty="0"/>
           </a:p>
         </p:txBody>
       </p:sp>
@@ -10321,28 +10186,24 @@
               <a:rPr lang="en-US" dirty="0"/>
               <a:t>Persona interact with software</a:t>
             </a:r>
-            <a:endParaRPr lang="en-US" dirty="0"/>
           </a:p>
           <a:p>
             <a:r>
               <a:rPr lang="en-US" dirty="0"/>
               <a:t>Persona has a “need”</a:t>
             </a:r>
-            <a:endParaRPr lang="en-US" dirty="0"/>
           </a:p>
           <a:p>
             <a:r>
               <a:rPr lang="en-US" dirty="0"/>
               <a:t>Persona uses the software to solve the “need”,  in multiple steps. </a:t>
             </a:r>
-            <a:endParaRPr lang="en-US" dirty="0"/>
           </a:p>
           <a:p>
             <a:r>
               <a:rPr lang="en-US" dirty="0"/>
               <a:t>Persona’s need is solved,  he/she is happy</a:t>
             </a:r>
-            <a:endParaRPr lang="en-US" dirty="0"/>
           </a:p>
           <a:p>
             <a:endParaRPr lang="en-US" dirty="0"/>
@@ -10403,7 +10264,6 @@
               <a:rPr lang="en-US" dirty="0"/>
               <a:t>Persona – used in Visual Studio</a:t>
             </a:r>
-            <a:endParaRPr lang="en-US" dirty="0"/>
           </a:p>
         </p:txBody>
       </p:sp>
@@ -10433,7 +10293,6 @@
               <a:rPr lang="en-US" b="1" dirty="0"/>
               <a:t>Challenges for Visual Studio Team</a:t>
             </a:r>
-            <a:endParaRPr lang="en-US" b="1" dirty="0"/>
           </a:p>
           <a:p>
             <a:pPr lvl="1"/>
@@ -10441,7 +10300,6 @@
               <a:rPr lang="en-US" sz="1800" dirty="0"/>
               <a:t>there are millions of customers,  using the software in different ways, for different purpose…</a:t>
             </a:r>
-            <a:endParaRPr lang="en-US" sz="1800" dirty="0"/>
           </a:p>
           <a:p>
             <a:pPr lvl="2"/>
@@ -10457,7 +10315,6 @@
               <a:rPr lang="en-US" sz="1400" dirty="0"/>
               <a:t> Framework</a:t>
             </a:r>
-            <a:endParaRPr lang="en-US" sz="1400" dirty="0"/>
           </a:p>
           <a:p>
             <a:pPr lvl="2"/>
@@ -10465,7 +10322,6 @@
               <a:rPr lang="en-US" sz="1400" dirty="0"/>
               <a:t>Hobbyist,  students, professionals, </a:t>
             </a:r>
-            <a:endParaRPr lang="en-US" sz="1400" dirty="0"/>
           </a:p>
           <a:p>
             <a:pPr lvl="2"/>
@@ -10473,7 +10329,6 @@
               <a:rPr lang="en-US" sz="1400" dirty="0"/>
               <a:t>Server, PC, embedded, web, </a:t>
             </a:r>
-            <a:endParaRPr lang="en-US" sz="1400" dirty="0"/>
           </a:p>
           <a:p>
             <a:pPr lvl="2"/>
@@ -10481,7 +10336,6 @@
               <a:rPr lang="en-US" sz="1400" dirty="0"/>
               <a:t>Team size – 1..1000</a:t>
             </a:r>
-            <a:endParaRPr lang="en-US" sz="1400" dirty="0"/>
           </a:p>
           <a:p>
             <a:pPr lvl="2"/>
@@ -10489,7 +10343,6 @@
               <a:rPr lang="en-US" sz="1400" dirty="0"/>
               <a:t>Different culture and country</a:t>
             </a:r>
-            <a:endParaRPr lang="en-US" sz="1400" dirty="0"/>
           </a:p>
           <a:p>
             <a:pPr lvl="1"/>
@@ -10497,7 +10350,6 @@
               <a:rPr lang="en-US" sz="1800" dirty="0"/>
               <a:t>how to design the next version to satisfy most of them?</a:t>
             </a:r>
-            <a:endParaRPr lang="en-US" sz="1800" dirty="0"/>
           </a:p>
           <a:p>
             <a:pPr lvl="1"/>
@@ -10505,7 +10357,6 @@
               <a:rPr lang="en-US" sz="1800" dirty="0"/>
               <a:t>How to make sure the target customers get the benefit from end-to-end?</a:t>
             </a:r>
-            <a:endParaRPr lang="en-US" sz="1800" dirty="0"/>
           </a:p>
           <a:p>
             <a:pPr lvl="1"/>
@@ -10513,7 +10364,6 @@
               <a:rPr lang="en-US" sz="1800" dirty="0"/>
               <a:t>There are 500 developers working in VS team,  how do we convince all of them agree on serving the same group of customers?</a:t>
             </a:r>
-            <a:endParaRPr lang="en-US" sz="1800" dirty="0"/>
           </a:p>
         </p:txBody>
       </p:sp>
@@ -10526,7 +10376,7 @@
           <p:nvPr/>
         </p:nvPicPr>
         <p:blipFill>
-          <a:blip r:embed="rId1"/>
+          <a:blip r:embed="rId2"/>
           <a:stretch>
             <a:fillRect/>
           </a:stretch>
@@ -10550,7 +10400,7 @@
           <p:nvPr/>
         </p:nvPicPr>
         <p:blipFill>
-          <a:blip r:embed="rId2"/>
+          <a:blip r:embed="rId3"/>
           <a:stretch>
             <a:fillRect/>
           </a:stretch>
@@ -10574,7 +10424,7 @@
           <p:nvPr/>
         </p:nvPicPr>
         <p:blipFill>
-          <a:blip r:embed="rId3"/>
+          <a:blip r:embed="rId4"/>
           <a:stretch>
             <a:fillRect/>
           </a:stretch>
@@ -10829,14 +10679,14 @@
         <p:nvPicPr>
           <p:cNvPr id="6" name="内容占位符 5"/>
           <p:cNvPicPr>
-            <a:picLocks noChangeAspect="1"/>
+            <a:picLocks noGrp="1" noChangeAspect="1"/>
           </p:cNvPicPr>
           <p:nvPr>
             <p:ph idx="1"/>
           </p:nvPr>
         </p:nvPicPr>
         <p:blipFill>
-          <a:blip r:embed="rId1"/>
+          <a:blip r:embed="rId2"/>
           <a:stretch>
             <a:fillRect/>
           </a:stretch>
@@ -10945,14 +10795,14 @@
         <p:nvPicPr>
           <p:cNvPr id="4" name="内容占位符 3"/>
           <p:cNvPicPr>
-            <a:picLocks noChangeAspect="1"/>
+            <a:picLocks noGrp="1" noChangeAspect="1"/>
           </p:cNvPicPr>
           <p:nvPr>
             <p:ph idx="1"/>
           </p:nvPr>
         </p:nvPicPr>
         <p:blipFill>
-          <a:blip r:embed="rId1"/>
+          <a:blip r:embed="rId2"/>
           <a:stretch>
             <a:fillRect/>
           </a:stretch>
@@ -11053,7 +10903,7 @@
           <p:nvPr/>
         </p:nvPicPr>
         <p:blipFill>
-          <a:blip r:embed="rId1"/>
+          <a:blip r:embed="rId2"/>
           <a:stretch>
             <a:fillRect/>
           </a:stretch>
@@ -11150,7 +11000,6 @@
               <a:rPr lang="zh-CN" altLang="en-US" dirty="0"/>
               <a:t>典型用户的模板可以包括：</a:t>
             </a:r>
-            <a:endParaRPr lang="zh-CN" altLang="en-US" dirty="0"/>
           </a:p>
           <a:p>
             <a:pPr marL="0" indent="0">
@@ -11380,7 +11229,6 @@
               <a:rPr lang="zh-CN" altLang="en-US" dirty="0"/>
               <a:t>用户的偏好</a:t>
             </a:r>
-            <a:endParaRPr lang="zh-CN" altLang="en-US" dirty="0"/>
           </a:p>
         </p:txBody>
       </p:sp>
@@ -11544,7 +11392,6 @@
               <a:rPr lang="zh-CN" altLang="en-US" dirty="0"/>
               <a:t>无卡取现”功能的强大：</a:t>
             </a:r>
-            <a:endParaRPr lang="zh-CN" altLang="en-US" dirty="0"/>
           </a:p>
           <a:p>
             <a:endParaRPr lang="en-US" dirty="0"/>
@@ -11566,7 +11413,6 @@
               <a:rPr lang="en-US" altLang="zh-CN" dirty="0"/>
               <a:t>……</a:t>
             </a:r>
-            <a:endParaRPr lang="en-US" altLang="zh-CN" dirty="0"/>
           </a:p>
           <a:p>
             <a:endParaRPr lang="en-US" dirty="0"/>
@@ -11582,7 +11428,7 @@
           <p:nvPr/>
         </p:nvPicPr>
         <p:blipFill rotWithShape="1">
-          <a:blip r:embed="rId1">
+          <a:blip r:embed="rId3">
             <a:extLst>
               <a:ext uri="{28A0092B-C50C-407E-A947-70E740481C1C}">
                 <a14:useLocalDpi xmlns:a14="http://schemas.microsoft.com/office/drawing/2010/main" val="0"/>
@@ -11700,8 +11546,20 @@
                 <a:tableStyleId>{5C22544A-7EE6-4342-B048-85BDC9FD1C3A}</a:tableStyleId>
               </a:tblPr>
               <a:tblGrid>
-                <a:gridCol w="3402013"/>
-                <a:gridCol w="3402013"/>
+                <a:gridCol w="3402013">
+                  <a:extLst>
+                    <a:ext uri="{9D8B030D-6E8A-4147-A177-3AD203B41FA5}">
+                      <a16:colId xmlns:a16="http://schemas.microsoft.com/office/drawing/2014/main" val="20000"/>
+                    </a:ext>
+                  </a:extLst>
+                </a:gridCol>
+                <a:gridCol w="3402013">
+                  <a:extLst>
+                    <a:ext uri="{9D8B030D-6E8A-4147-A177-3AD203B41FA5}">
+                      <a16:colId xmlns:a16="http://schemas.microsoft.com/office/drawing/2014/main" val="20001"/>
+                    </a:ext>
+                  </a:extLst>
+                </a:gridCol>
               </a:tblGrid>
               <a:tr h="661353">
                 <a:tc gridSpan="2">
@@ -11720,8 +11578,20 @@
                   <a:tcPr/>
                 </a:tc>
                 <a:tc hMerge="1">
+                  <a:txBody>
+                    <a:bodyPr/>
+                    <a:lstStyle/>
+                    <a:p>
+                      <a:endParaRPr lang="zh-CN"/>
+                    </a:p>
+                  </a:txBody>
                   <a:tcPr/>
                 </a:tc>
+                <a:extLst>
+                  <a:ext uri="{0D108BD9-81ED-4DB2-BD59-A6C34878D82A}">
+                    <a16:rowId xmlns:a16="http://schemas.microsoft.com/office/drawing/2014/main" val="10000"/>
+                  </a:ext>
+                </a:extLst>
               </a:tr>
               <a:tr h="1432203">
                 <a:tc>
@@ -11754,6 +11624,11 @@
                   </a:txBody>
                   <a:tcPr/>
                 </a:tc>
+                <a:extLst>
+                  <a:ext uri="{0D108BD9-81ED-4DB2-BD59-A6C34878D82A}">
+                    <a16:rowId xmlns:a16="http://schemas.microsoft.com/office/drawing/2014/main" val="10001"/>
+                  </a:ext>
+                </a:extLst>
               </a:tr>
               <a:tr h="2573694">
                 <a:tc>
@@ -11820,13 +11695,6 @@
                         </a:rPr>
                         <a:t>]</a:t>
                       </a:r>
-                      <a:endParaRPr lang="en-US" altLang="zh-CN" sz="2400" dirty="0">
-                        <a:highlight>
-                          <a:srgbClr val="FFFF00"/>
-                        </a:highlight>
-                        <a:latin typeface="+mj-ea"/>
-                        <a:ea typeface="+mj-ea"/>
-                      </a:endParaRPr>
                     </a:p>
                     <a:p>
                       <a:pPr algn="ctr"/>
@@ -11895,10 +11763,6 @@
                         </a:rPr>
                         <a:t> </a:t>
                       </a:r>
-                      <a:endParaRPr lang="en-US" altLang="zh-CN" sz="2400" dirty="0">
-                        <a:latin typeface="+mj-ea"/>
-                        <a:ea typeface="+mj-ea"/>
-                      </a:endParaRPr>
                     </a:p>
                     <a:p>
                       <a:pPr algn="ctr"/>
@@ -12072,10 +11936,6 @@
                         </a:rPr>
                         <a:t>, </a:t>
                       </a:r>
-                      <a:endParaRPr lang="en-US" altLang="zh-CN" sz="2400" dirty="0">
-                        <a:latin typeface="+mj-ea"/>
-                        <a:ea typeface="+mj-ea"/>
-                      </a:endParaRPr>
                     </a:p>
                     <a:p>
                       <a:pPr algn="ctr"/>
@@ -12094,6 +11954,11 @@
                   </a:txBody>
                   <a:tcPr/>
                 </a:tc>
+                <a:extLst>
+                  <a:ext uri="{0D108BD9-81ED-4DB2-BD59-A6C34878D82A}">
+                    <a16:rowId xmlns:a16="http://schemas.microsoft.com/office/drawing/2014/main" val="10002"/>
+                  </a:ext>
+                </a:extLst>
               </a:tr>
             </a:tbl>
           </a:graphicData>
@@ -12108,10 +11973,10 @@
           <p:nvPr/>
         </p:nvPicPr>
         <p:blipFill>
-          <a:blip r:embed="rId1">
+          <a:blip>
             <a:extLst>
               <a:ext uri="{96DAC541-7B7A-43D3-8B79-37D633B846F1}">
-                <asvg:svgBlip xmlns:asvg="http://schemas.microsoft.com/office/drawing/2016/SVG/main" r:embed="rId2"/>
+                <asvg:svgBlip xmlns:asvg="http://schemas.microsoft.com/office/drawing/2016/SVG/main" r:embed="rId3"/>
               </a:ext>
             </a:extLst>
           </a:blip>
@@ -12138,7 +12003,7 @@
           <p:nvPr/>
         </p:nvPicPr>
         <p:blipFill>
-          <a:blip r:embed="rId3">
+          <a:blip>
             <a:extLst>
               <a:ext uri="{96DAC541-7B7A-43D3-8B79-37D633B846F1}">
                 <asvg:svgBlip xmlns:asvg="http://schemas.microsoft.com/office/drawing/2016/SVG/main" r:embed="rId4"/>
@@ -12391,7 +12256,7 @@
           <p:nvPr/>
         </p:nvPicPr>
         <p:blipFill>
-          <a:blip r:embed="rId1"/>
+          <a:blip r:embed="rId2"/>
           <a:stretch>
             <a:fillRect/>
           </a:stretch>
@@ -12415,7 +12280,7 @@
           <p:nvPr/>
         </p:nvPicPr>
         <p:blipFill>
-          <a:blip r:embed="rId2"/>
+          <a:blip r:embed="rId3"/>
           <a:stretch>
             <a:fillRect/>
           </a:stretch>
@@ -12439,7 +12304,7 @@
           <p:nvPr/>
         </p:nvPicPr>
         <p:blipFill>
-          <a:blip r:embed="rId3"/>
+          <a:blip r:embed="rId4"/>
           <a:stretch>
             <a:fillRect/>
           </a:stretch>
@@ -12803,7 +12668,6 @@
               <a:rPr lang="en-US" dirty="0"/>
               <a:t>]</a:t>
             </a:r>
-            <a:endParaRPr lang="en-US" dirty="0"/>
           </a:p>
           <a:p>
             <a:pPr lvl="1"/>
@@ -12851,7 +12715,6 @@
               <a:rPr lang="en-US" altLang="zh-CN" dirty="0"/>
               <a:t>?</a:t>
             </a:r>
-            <a:endParaRPr lang="en-US" altLang="zh-CN" dirty="0"/>
           </a:p>
           <a:p>
             <a:pPr lvl="1"/>
@@ -12886,7 +12749,6 @@
               <a:rPr lang="en-US" dirty="0"/>
               <a:t>]</a:t>
             </a:r>
-            <a:endParaRPr lang="en-US" dirty="0"/>
           </a:p>
           <a:p>
             <a:pPr lvl="1"/>
@@ -12917,7 +12779,6 @@
               <a:rPr lang="en-US" dirty="0"/>
               <a:t> ]</a:t>
             </a:r>
-            <a:endParaRPr lang="en-US" dirty="0"/>
           </a:p>
           <a:p>
             <a:pPr lvl="1"/>
@@ -12940,7 +12801,6 @@
               <a:rPr lang="en-US" dirty="0"/>
               <a:t> ]</a:t>
             </a:r>
-            <a:endParaRPr lang="en-US" dirty="0"/>
           </a:p>
           <a:p>
             <a:pPr lvl="1"/>
@@ -13070,12 +12930,6 @@
           <a:p>
             <a:pPr lvl="1"/>
             <a:r>
-              <a:rPr lang="en-US" dirty="0">
-                <a:hlinkClick r:id="rId1"/>
-              </a:rPr>
-              <a:t>https://www.zhihu.com/question/19572438</a:t>
-            </a:r>
-            <a:r>
               <a:rPr lang="en-US" dirty="0"/>
               <a:t>  </a:t>
             </a:r>
@@ -13083,23 +12937,25 @@
               <a:rPr lang="en-US" altLang="zh-CN" dirty="0"/>
               <a:t>Axure</a:t>
             </a:r>
-            <a:endParaRPr lang="en-US" dirty="0"/>
-          </a:p>
-          <a:p>
-            <a:pPr lvl="1"/>
-            <a:r>
-              <a:rPr lang="en-US" dirty="0">
-                <a:hlinkClick r:id="rId2"/>
-              </a:rPr>
-              <a:t>https://zhuanlan.zhihu.com/p/34082256</a:t>
+            <a:r>
+              <a:rPr lang="zh-CN" altLang="en-US" dirty="0"/>
+              <a:t>，</a:t>
             </a:r>
             <a:r>
               <a:rPr lang="en-US" dirty="0"/>
-              <a:t>    </a:t>
+              <a:t>  </a:t>
             </a:r>
             <a:r>
               <a:rPr lang="zh-CN" altLang="en-US" dirty="0"/>
-              <a:t>墨刀</a:t>
+              <a:t>墨刀，在 </a:t>
+            </a:r>
+            <a:r>
+              <a:rPr lang="en-US" altLang="zh-CN" dirty="0"/>
+              <a:t>AI </a:t>
+            </a:r>
+            <a:r>
+              <a:rPr lang="zh-CN" altLang="en-US"/>
+              <a:t>时代，老工具已经被淘汰</a:t>
             </a:r>
             <a:endParaRPr lang="en-US" dirty="0"/>
           </a:p>
@@ -13220,7 +13076,6 @@
               <a:rPr lang="zh-CN" altLang="zh-CN" sz="2000" dirty="0"/>
               <a:t>。</a:t>
             </a:r>
-            <a:endParaRPr lang="zh-CN" altLang="zh-CN" sz="2000" dirty="0"/>
           </a:p>
           <a:p>
             <a:endParaRPr lang="zh-CN" altLang="en-US" dirty="0"/>
@@ -13236,7 +13091,7 @@
           <p:nvPr/>
         </p:nvPicPr>
         <p:blipFill>
-          <a:blip r:embed="rId1">
+          <a:blip r:embed="rId2" cstate="print">
             <a:extLst>
               <a:ext uri="{28A0092B-C50C-407E-A947-70E740481C1C}">
                 <a14:useLocalDpi xmlns:a14="http://schemas.microsoft.com/office/drawing/2010/main" val="0"/>
@@ -13295,7 +13150,7 @@
     <p:bg>
       <p:bgPr>
         <a:blipFill dpi="0" rotWithShape="1">
-          <a:blip r:embed="rId1">
+          <a:blip r:embed="rId3">
             <a:lum/>
           </a:blip>
           <a:srcRect/>
@@ -13484,7 +13339,6 @@
               <a:rPr lang="en-US" sz="2400"/>
               <a:t>)</a:t>
             </a:r>
-            <a:endParaRPr lang="en-US" sz="2400"/>
           </a:p>
           <a:p>
             <a:endParaRPr lang="en-US" sz="2400"/>
@@ -13511,7 +13365,7 @@
           <p:nvPr/>
         </p:nvPicPr>
         <p:blipFill>
-          <a:blip r:embed="rId2">
+          <a:blip r:embed="rId4">
             <a:extLst>
               <a:ext uri="{28A0092B-C50C-407E-A947-70E740481C1C}">
                 <a14:useLocalDpi xmlns:a14="http://schemas.microsoft.com/office/drawing/2010/main" val="0"/>
@@ -13552,7 +13406,7 @@
           <p:nvPr/>
         </p:nvPicPr>
         <p:blipFill>
-          <a:blip r:embed="rId3">
+          <a:blip r:embed="rId5">
             <a:extLst>
               <a:ext uri="{28A0092B-C50C-407E-A947-70E740481C1C}">
                 <a14:useLocalDpi xmlns:a14="http://schemas.microsoft.com/office/drawing/2010/main" val="0"/>
@@ -13683,7 +13537,6 @@
               <a:rPr lang="en-US" altLang="zh-CN" dirty="0"/>
               <a:t>?</a:t>
             </a:r>
-            <a:endParaRPr lang="en-US" altLang="zh-CN" dirty="0"/>
           </a:p>
           <a:p>
             <a:pPr lvl="1"/>
@@ -13706,7 +13559,6 @@
               <a:rPr lang="en-US" dirty="0"/>
               <a:t>Senior Researcher</a:t>
             </a:r>
-            <a:endParaRPr lang="en-US" dirty="0"/>
           </a:p>
           <a:p>
             <a:pPr lvl="1"/>
@@ -13714,7 +13566,6 @@
               <a:rPr lang="en-US" dirty="0"/>
               <a:t>Junior Researcher</a:t>
             </a:r>
-            <a:endParaRPr lang="en-US" dirty="0"/>
           </a:p>
           <a:p>
             <a:pPr lvl="1"/>
@@ -13722,7 +13573,6 @@
               <a:rPr lang="en-US" dirty="0"/>
               <a:t>Students</a:t>
             </a:r>
-            <a:endParaRPr lang="en-US" dirty="0"/>
           </a:p>
           <a:p>
             <a:r>
@@ -14213,7 +14063,6 @@
               <a:rPr lang="en-US" dirty="0"/>
               <a:t>Researcher working in industrial lab (e.g. MSR researcher)</a:t>
             </a:r>
-            <a:endParaRPr lang="en-US" dirty="0"/>
           </a:p>
           <a:p>
             <a:pPr lvl="1"/>
@@ -14221,7 +14070,6 @@
               <a:rPr lang="en-US" altLang="zh-CN" dirty="0"/>
               <a:t>Education: PhD,  Age: &gt;=35, h-index &gt; 20, </a:t>
             </a:r>
-            <a:endParaRPr lang="en-US" altLang="zh-CN" dirty="0"/>
           </a:p>
           <a:p>
             <a:pPr lvl="1"/>
@@ -14229,7 +14077,6 @@
               <a:rPr lang="en-US" altLang="zh-CN" dirty="0"/>
               <a:t>PAIN: </a:t>
             </a:r>
-            <a:endParaRPr lang="en-US" altLang="zh-CN" dirty="0"/>
           </a:p>
           <a:p>
             <a:pPr lvl="2"/>
@@ -14237,7 +14084,6 @@
               <a:rPr lang="en-US" altLang="zh-CN" dirty="0"/>
               <a:t>Hiring someone / check background</a:t>
             </a:r>
-            <a:endParaRPr lang="en-US" altLang="zh-CN" dirty="0"/>
           </a:p>
           <a:p>
             <a:pPr lvl="2"/>
@@ -14245,7 +14091,6 @@
               <a:rPr lang="en-US" altLang="zh-CN" dirty="0"/>
               <a:t>As Chair person, pick reviewers, PC member</a:t>
             </a:r>
-            <a:endParaRPr lang="en-US" altLang="zh-CN" dirty="0"/>
           </a:p>
           <a:p>
             <a:pPr lvl="2"/>
@@ -14253,7 +14098,6 @@
               <a:rPr lang="en-US" altLang="zh-CN" dirty="0"/>
               <a:t>Read/organize paper</a:t>
             </a:r>
-            <a:endParaRPr lang="en-US" altLang="zh-CN" dirty="0"/>
           </a:p>
           <a:p>
             <a:pPr lvl="1"/>
@@ -14261,7 +14105,6 @@
               <a:rPr lang="en-US" dirty="0"/>
               <a:t>Care about  “my rank” in the domain,  and correctness, completeness of my profile, </a:t>
             </a:r>
-            <a:endParaRPr lang="en-US" dirty="0"/>
           </a:p>
           <a:p>
             <a:pPr lvl="1"/>
@@ -14269,7 +14112,6 @@
               <a:rPr lang="en-US" dirty="0"/>
               <a:t>Care about rank of my dept. </a:t>
             </a:r>
-            <a:endParaRPr lang="en-US" dirty="0"/>
           </a:p>
           <a:p>
             <a:pPr lvl="1"/>
@@ -14277,7 +14119,6 @@
               <a:rPr lang="en-US" dirty="0"/>
               <a:t>Already know lots of people in such domain,  knowing  people is not top priority</a:t>
             </a:r>
-            <a:endParaRPr lang="en-US" dirty="0"/>
           </a:p>
           <a:p>
             <a:pPr lvl="1"/>
@@ -14285,7 +14126,6 @@
               <a:rPr lang="en-US" dirty="0"/>
               <a:t>Big influencer</a:t>
             </a:r>
-            <a:endParaRPr lang="en-US" dirty="0"/>
           </a:p>
           <a:p>
             <a:endParaRPr lang="en-US" dirty="0"/>
@@ -14301,7 +14141,7 @@
           <p:nvPr/>
         </p:nvPicPr>
         <p:blipFill>
-          <a:blip r:embed="rId1" cstate="print"/>
+          <a:blip r:embed="rId2" cstate="print"/>
           <a:stretch>
             <a:fillRect/>
           </a:stretch>
@@ -15181,7 +15021,6 @@
               <a:rPr lang="en-US" sz="2800" dirty="0"/>
               <a:t> professor</a:t>
             </a:r>
-            <a:endParaRPr lang="en-US" sz="2800" dirty="0"/>
           </a:p>
           <a:p>
             <a:pPr lvl="1"/>
@@ -15189,7 +15028,6 @@
               <a:rPr lang="en-US" altLang="zh-CN" sz="2000" dirty="0"/>
               <a:t>Handling both teaching and research</a:t>
             </a:r>
-            <a:endParaRPr lang="en-US" altLang="zh-CN" sz="2000" dirty="0"/>
           </a:p>
           <a:p>
             <a:pPr lvl="1"/>
@@ -15197,7 +15035,6 @@
               <a:rPr lang="en-US" altLang="zh-CN" sz="2000" dirty="0"/>
               <a:t>PAIN:</a:t>
             </a:r>
-            <a:endParaRPr lang="en-US" altLang="zh-CN" sz="2000" dirty="0"/>
           </a:p>
           <a:p>
             <a:pPr lvl="2"/>
@@ -15205,7 +15042,6 @@
               <a:rPr lang="en-US" altLang="zh-CN" sz="2000" b="1" dirty="0"/>
               <a:t>How to let more people know about my work?</a:t>
             </a:r>
-            <a:endParaRPr lang="en-US" altLang="zh-CN" sz="2000" b="1" dirty="0"/>
           </a:p>
           <a:p>
             <a:pPr lvl="2"/>
@@ -15213,7 +15049,6 @@
               <a:rPr lang="en-US" altLang="zh-CN" sz="2000" b="1" dirty="0"/>
               <a:t>Show my performance</a:t>
             </a:r>
-            <a:endParaRPr lang="en-US" altLang="zh-CN" sz="2000" b="1" dirty="0"/>
           </a:p>
           <a:p>
             <a:pPr lvl="2"/>
@@ -15221,7 +15056,6 @@
               <a:rPr lang="en-US" altLang="zh-CN" sz="2000" dirty="0"/>
               <a:t>Write paper with good reference</a:t>
             </a:r>
-            <a:endParaRPr lang="en-US" altLang="zh-CN" sz="2000" dirty="0"/>
           </a:p>
           <a:p>
             <a:pPr lvl="2"/>
@@ -15229,7 +15063,6 @@
               <a:rPr lang="en-US" altLang="zh-CN" sz="2000" dirty="0"/>
               <a:t>Generate a  list of paper for a class / curriculum </a:t>
             </a:r>
-            <a:endParaRPr lang="en-US" altLang="zh-CN" sz="2000" dirty="0"/>
           </a:p>
           <a:p>
             <a:pPr lvl="2"/>
@@ -15241,7 +15074,6 @@
               <a:rPr lang="en-US" sz="2000" dirty="0"/>
               <a:t>,  browse, and  attending the right events. </a:t>
             </a:r>
-            <a:endParaRPr lang="en-US" sz="2000" dirty="0"/>
           </a:p>
           <a:p>
             <a:pPr lvl="1"/>
@@ -15249,7 +15081,6 @@
               <a:rPr lang="en-US" sz="2000" b="1" dirty="0"/>
               <a:t>Heavy user</a:t>
             </a:r>
-            <a:endParaRPr lang="en-US" sz="2000" b="1" dirty="0"/>
           </a:p>
           <a:p>
             <a:pPr lvl="1"/>
@@ -15257,7 +15088,6 @@
               <a:rPr lang="en-US" sz="2000" b="1" dirty="0"/>
               <a:t>Influencer – can influence students and peers.</a:t>
             </a:r>
-            <a:endParaRPr lang="en-US" sz="2000" b="1" dirty="0"/>
           </a:p>
         </p:txBody>
       </p:sp>
@@ -15848,7 +15678,6 @@
               <a:rPr lang="en-US" dirty="0"/>
               <a:t>John - Scenarios</a:t>
             </a:r>
-            <a:endParaRPr lang="en-US" dirty="0"/>
           </a:p>
         </p:txBody>
       </p:sp>
@@ -15878,7 +15707,6 @@
               <a:rPr lang="en-US" altLang="zh-CN" dirty="0"/>
               <a:t>Show my network (co-author, co-occurrence)  in my home page</a:t>
             </a:r>
-            <a:endParaRPr lang="en-US" altLang="zh-CN" dirty="0"/>
           </a:p>
           <a:p>
             <a:r>
@@ -15893,28 +15721,24 @@
               <a:rPr lang="en-US" altLang="zh-CN" dirty="0"/>
               <a:t>. </a:t>
             </a:r>
-            <a:endParaRPr lang="en-US" altLang="zh-CN" dirty="0"/>
           </a:p>
           <a:p>
             <a:r>
               <a:rPr lang="en-US" altLang="zh-CN" dirty="0"/>
               <a:t>Track Conferences</a:t>
             </a:r>
-            <a:endParaRPr lang="en-US" altLang="zh-CN" dirty="0"/>
           </a:p>
           <a:p>
             <a:r>
               <a:rPr lang="en-US" altLang="zh-CN" dirty="0"/>
               <a:t>See the timeline of a field (e.g. the up and down in papers about “Machine Learning”). </a:t>
             </a:r>
-            <a:endParaRPr lang="en-US" altLang="zh-CN" dirty="0"/>
           </a:p>
           <a:p>
             <a:r>
               <a:rPr lang="en-US" altLang="zh-CN" dirty="0"/>
               <a:t>User contribution:</a:t>
             </a:r>
-            <a:endParaRPr lang="en-US" altLang="zh-CN" dirty="0"/>
           </a:p>
           <a:p>
             <a:pPr lvl="1"/>
@@ -16028,21 +15852,18 @@
               <a:rPr lang="en-US" dirty="0"/>
               <a:t>PhD student major in CS</a:t>
             </a:r>
-            <a:endParaRPr lang="en-US" dirty="0"/>
           </a:p>
           <a:p>
             <a:r>
               <a:rPr lang="en-US" dirty="0"/>
               <a:t>Frequently go online looking for paper for his/her own research,  </a:t>
             </a:r>
-            <a:endParaRPr lang="en-US" dirty="0"/>
           </a:p>
           <a:p>
             <a:r>
               <a:rPr lang="en-US" altLang="zh-CN" dirty="0"/>
               <a:t>PAIN? </a:t>
             </a:r>
-            <a:endParaRPr lang="en-US" altLang="zh-CN" dirty="0"/>
           </a:p>
           <a:p>
             <a:pPr lvl="1"/>
@@ -16066,7 +15887,6 @@
               <a:rPr lang="en-US" dirty="0"/>
               <a:t> important paper</a:t>
             </a:r>
-            <a:endParaRPr lang="en-US" dirty="0"/>
           </a:p>
           <a:p>
             <a:pPr lvl="1"/>
@@ -16074,7 +15894,6 @@
               <a:rPr lang="en-US" dirty="0"/>
               <a:t>Need a comprehensive source of papers for homework and project</a:t>
             </a:r>
-            <a:endParaRPr lang="en-US" dirty="0"/>
           </a:p>
           <a:p>
             <a:pPr lvl="1"/>
@@ -16082,7 +15901,6 @@
               <a:rPr lang="en-US" dirty="0"/>
               <a:t>Check out researcher profiles (to help apply for advanced study)</a:t>
             </a:r>
-            <a:endParaRPr lang="en-US" dirty="0"/>
           </a:p>
           <a:p>
             <a:pPr lvl="1"/>
@@ -16090,7 +15908,6 @@
               <a:rPr lang="en-US" dirty="0"/>
               <a:t>Keep track of new papers</a:t>
             </a:r>
-            <a:endParaRPr lang="en-US" dirty="0"/>
           </a:p>
           <a:p>
             <a:pPr lvl="1"/>
@@ -16102,7 +15919,6 @@
               <a:rPr lang="en-US" dirty="0"/>
               <a:t> </a:t>
             </a:r>
-            <a:endParaRPr lang="en-US" dirty="0"/>
           </a:p>
           <a:p>
             <a:pPr lvl="1"/>
@@ -16118,14 +15934,12 @@
               <a:rPr lang="en-US" altLang="zh-CN" dirty="0"/>
               <a:t> language</a:t>
             </a:r>
-            <a:endParaRPr lang="en-US" altLang="zh-CN" dirty="0"/>
           </a:p>
           <a:p>
             <a:r>
               <a:rPr lang="en-US" altLang="zh-CN" dirty="0"/>
               <a:t>500K IT students in China</a:t>
             </a:r>
-            <a:endParaRPr lang="en-US" altLang="zh-CN" dirty="0"/>
           </a:p>
           <a:p>
             <a:pPr lvl="1"/>
@@ -16719,7 +16533,6 @@
               <a:rPr lang="en-US" dirty="0"/>
               <a:t> != sum(functions)</a:t>
             </a:r>
-            <a:endParaRPr lang="en-US" dirty="0"/>
           </a:p>
         </p:txBody>
       </p:sp>
@@ -16745,7 +16558,6 @@
               <a:rPr lang="zh-CN" altLang="en-US" dirty="0"/>
               <a:t>茶壶的功能</a:t>
             </a:r>
-            <a:endParaRPr lang="zh-CN" altLang="en-US" dirty="0"/>
           </a:p>
           <a:p>
             <a:pPr lvl="1" fontAlgn="ctr"/>
@@ -16753,7 +16565,6 @@
               <a:rPr lang="zh-CN" altLang="en-US" dirty="0"/>
               <a:t>茶壶盖</a:t>
             </a:r>
-            <a:endParaRPr lang="zh-CN" altLang="en-US" dirty="0"/>
           </a:p>
           <a:p>
             <a:pPr lvl="1" fontAlgn="ctr"/>
@@ -16761,7 +16572,6 @@
               <a:rPr lang="zh-CN" altLang="en-US" dirty="0"/>
               <a:t>茶壶体</a:t>
             </a:r>
-            <a:endParaRPr lang="zh-CN" altLang="en-US" dirty="0"/>
           </a:p>
           <a:p>
             <a:pPr lvl="1" fontAlgn="ctr"/>
@@ -16769,7 +16579,6 @@
               <a:rPr lang="zh-CN" altLang="en-US" dirty="0"/>
               <a:t>茶壶把</a:t>
             </a:r>
-            <a:endParaRPr lang="zh-CN" altLang="en-US" dirty="0"/>
           </a:p>
           <a:p>
             <a:pPr lvl="1" fontAlgn="ctr"/>
@@ -16777,7 +16586,6 @@
               <a:rPr lang="zh-CN" altLang="en-US" dirty="0"/>
               <a:t>茶壶嘴</a:t>
             </a:r>
-            <a:endParaRPr lang="zh-CN" altLang="en-US" dirty="0"/>
           </a:p>
           <a:p>
             <a:pPr fontAlgn="ctr"/>
@@ -16785,7 +16593,6 @@
               <a:rPr lang="zh-CN" altLang="en-US" dirty="0"/>
               <a:t>各个功能还要有机结合起来，满足用户的需求</a:t>
             </a:r>
-            <a:endParaRPr lang="zh-CN" altLang="en-US" dirty="0"/>
           </a:p>
           <a:p>
             <a:pPr fontAlgn="ctr"/>
@@ -16793,7 +16600,6 @@
               <a:rPr lang="zh-CN" altLang="en-US" dirty="0"/>
               <a:t>下面的茶壶满足了用户的需求了么？</a:t>
             </a:r>
-            <a:endParaRPr lang="zh-CN" altLang="en-US" dirty="0"/>
           </a:p>
         </p:txBody>
       </p:sp>
@@ -16846,7 +16652,6 @@
               <a:rPr lang="en-US" dirty="0"/>
               <a:t>Brian - Scenarios</a:t>
             </a:r>
-            <a:endParaRPr lang="en-US" dirty="0"/>
           </a:p>
         </p:txBody>
       </p:sp>
@@ -16876,14 +16681,12 @@
               <a:rPr lang="en-US" altLang="zh-CN" dirty="0"/>
               <a:t>Notify me when something happens</a:t>
             </a:r>
-            <a:endParaRPr lang="en-US" altLang="zh-CN" dirty="0"/>
           </a:p>
           <a:p>
             <a:r>
               <a:rPr lang="en-US" altLang="zh-CN" dirty="0"/>
               <a:t>Get all papers in one field</a:t>
             </a:r>
-            <a:endParaRPr lang="en-US" altLang="zh-CN" dirty="0"/>
           </a:p>
           <a:p>
             <a:pPr lvl="1"/>
@@ -16891,21 +16694,18 @@
               <a:rPr lang="en-US" altLang="zh-CN" dirty="0"/>
               <a:t>Related papers</a:t>
             </a:r>
-            <a:endParaRPr lang="en-US" altLang="zh-CN" dirty="0"/>
           </a:p>
           <a:p>
             <a:r>
               <a:rPr lang="en-US" altLang="zh-CN" dirty="0"/>
               <a:t>Check the importance of journals, conferences</a:t>
             </a:r>
-            <a:endParaRPr lang="en-US" altLang="zh-CN" dirty="0"/>
           </a:p>
           <a:p>
             <a:r>
               <a:rPr lang="en-US" altLang="zh-CN" dirty="0"/>
               <a:t>Name disambiguation</a:t>
             </a:r>
-            <a:endParaRPr lang="en-US" altLang="zh-CN" dirty="0"/>
           </a:p>
           <a:p>
             <a:pPr lvl="1"/>
@@ -16913,14 +16713,12 @@
               <a:rPr lang="en-US" altLang="zh-CN" dirty="0"/>
               <a:t>Find Michael Cohen</a:t>
             </a:r>
-            <a:endParaRPr lang="en-US" altLang="zh-CN" dirty="0"/>
           </a:p>
           <a:p>
             <a:r>
               <a:rPr lang="en-US" dirty="0"/>
               <a:t>Find out the “family tree” of a scholar, to understand his/her impact</a:t>
             </a:r>
-            <a:endParaRPr lang="en-US" dirty="0"/>
           </a:p>
         </p:txBody>
       </p:sp>
@@ -16941,7 +16739,7 @@
     <p:bg>
       <p:bgPr>
         <a:blipFill dpi="0" rotWithShape="1">
-          <a:blip r:embed="rId1">
+          <a:blip r:embed="rId2">
             <a:lum/>
           </a:blip>
           <a:srcRect/>
@@ -17144,7 +16942,7 @@
         </p:xfrm>
         <a:graphic>
           <a:graphicData uri="http://schemas.openxmlformats.org/drawingml/2006/diagram">
-            <dgm:relIds xmlns:dgm="http://schemas.openxmlformats.org/drawingml/2006/diagram" xmlns:r="http://schemas.openxmlformats.org/officeDocument/2006/relationships" r:dm="rId2" r:lo="rId3" r:qs="rId4" r:cs="rId5"/>
+            <dgm:relIds xmlns:dgm="http://schemas.openxmlformats.org/drawingml/2006/diagram" xmlns:r="http://schemas.openxmlformats.org/officeDocument/2006/relationships" r:dm="rId3" r:lo="rId4" r:qs="rId5" r:cs="rId6"/>
           </a:graphicData>
         </a:graphic>
       </p:graphicFrame>
@@ -17192,7 +16990,6 @@
               <a:rPr lang="en-US" dirty="0"/>
               <a:t>Scenario = User Story</a:t>
             </a:r>
-            <a:endParaRPr lang="en-US" dirty="0"/>
           </a:p>
         </p:txBody>
       </p:sp>
@@ -17227,7 +17024,7 @@
           <p:nvPr/>
         </p:nvPicPr>
         <p:blipFill>
-          <a:blip r:embed="rId1"/>
+          <a:blip r:embed="rId2"/>
           <a:stretch>
             <a:fillRect/>
           </a:stretch>
@@ -17353,7 +17150,6 @@
               <a:rPr lang="en-US" dirty="0"/>
               <a:t>Spec</a:t>
             </a:r>
-            <a:endParaRPr lang="en-US" dirty="0"/>
           </a:p>
         </p:txBody>
       </p:sp>
@@ -17389,7 +17185,6 @@
               <a:rPr lang="en-US" altLang="zh-CN" dirty="0"/>
               <a:t>Functional Spec  </a:t>
             </a:r>
-            <a:endParaRPr lang="en-US" altLang="zh-CN" dirty="0"/>
           </a:p>
           <a:p>
             <a:pPr lvl="1"/>
@@ -17397,7 +17192,6 @@
               <a:rPr lang="en-US" altLang="zh-CN" dirty="0"/>
               <a:t>Tell people about a feature/function of a product, From user’s perspective</a:t>
             </a:r>
-            <a:endParaRPr lang="en-US" altLang="zh-CN" dirty="0"/>
           </a:p>
           <a:p>
             <a:pPr lvl="1"/>
@@ -17412,7 +17206,6 @@
               <a:rPr lang="en-US" altLang="zh-CN" dirty="0"/>
               <a:t>Technical Spec (aka design doc)</a:t>
             </a:r>
-            <a:endParaRPr lang="en-US" altLang="zh-CN" dirty="0"/>
           </a:p>
           <a:p>
             <a:pPr lvl="1"/>
@@ -17420,7 +17213,6 @@
               <a:rPr lang="en-US" altLang="zh-CN" dirty="0"/>
               <a:t>Tell the software team member or other partners how the function is implemented</a:t>
             </a:r>
-            <a:endParaRPr lang="en-US" altLang="zh-CN" dirty="0"/>
           </a:p>
           <a:p>
             <a:pPr lvl="1"/>
@@ -17920,28 +17712,24 @@
               <a:rPr lang="en-US" altLang="zh-CN" dirty="0"/>
               <a:t>)</a:t>
             </a:r>
-            <a:endParaRPr lang="en-US" altLang="zh-CN" dirty="0"/>
           </a:p>
           <a:p>
             <a:r>
               <a:rPr lang="en-US" altLang="zh-CN" dirty="0"/>
               <a:t>Each pair come up with one spec (10 minutes)</a:t>
             </a:r>
-            <a:endParaRPr lang="en-US" altLang="zh-CN" dirty="0"/>
           </a:p>
           <a:p>
             <a:r>
               <a:rPr lang="en-US" altLang="zh-CN" dirty="0"/>
               <a:t>Compare with your neighboring pair,  pick the winner</a:t>
             </a:r>
-            <a:endParaRPr lang="en-US" altLang="zh-CN" dirty="0"/>
           </a:p>
           <a:p>
             <a:r>
               <a:rPr lang="en-US" altLang="zh-CN" dirty="0"/>
               <a:t>Tell us the reason for win/lose</a:t>
             </a:r>
-            <a:endParaRPr lang="en-US" altLang="zh-CN" dirty="0"/>
           </a:p>
           <a:p>
             <a:pPr lvl="1"/>
@@ -17949,7 +17737,6 @@
               <a:rPr lang="en-US" altLang="zh-CN" dirty="0"/>
               <a:t>Good points of the winner</a:t>
             </a:r>
-            <a:endParaRPr lang="en-US" altLang="zh-CN" dirty="0"/>
           </a:p>
           <a:p>
             <a:pPr lvl="1"/>
@@ -17957,7 +17744,6 @@
               <a:rPr lang="en-US" altLang="zh-CN" dirty="0"/>
               <a:t>Weak areas for the loser</a:t>
             </a:r>
-            <a:endParaRPr lang="en-US" altLang="zh-CN" dirty="0"/>
           </a:p>
           <a:p>
             <a:endParaRPr lang="en-US" dirty="0"/>
@@ -18457,7 +18243,6 @@
               <a:rPr lang="en-US" altLang="zh-CN" dirty="0"/>
               <a:t>Definition: </a:t>
             </a:r>
-            <a:endParaRPr lang="en-US" altLang="zh-CN" dirty="0"/>
           </a:p>
           <a:p>
             <a:pPr lvl="1"/>
@@ -18465,21 +18250,18 @@
               <a:rPr lang="en-US" altLang="zh-CN" dirty="0"/>
               <a:t>what is “shoe”, “shoe laces”,  “tied shoe laces”, and “untied shoe laces”</a:t>
             </a:r>
-            <a:endParaRPr lang="en-US" altLang="zh-CN" dirty="0"/>
           </a:p>
           <a:p>
             <a:r>
               <a:rPr lang="en-US" altLang="zh-CN" dirty="0"/>
               <a:t>Benefit of  this feature “tie your shoe laces”</a:t>
             </a:r>
-            <a:endParaRPr lang="en-US" altLang="zh-CN" dirty="0"/>
           </a:p>
           <a:p>
             <a:r>
               <a:rPr lang="en-US" altLang="zh-CN" dirty="0"/>
               <a:t>The goal of the feature?  </a:t>
             </a:r>
-            <a:endParaRPr lang="en-US" altLang="zh-CN" dirty="0"/>
           </a:p>
           <a:p>
             <a:pPr lvl="1"/>
@@ -18487,21 +18269,18 @@
               <a:rPr lang="en-US" altLang="zh-CN" dirty="0"/>
               <a:t>What does “success” look like?</a:t>
             </a:r>
-            <a:endParaRPr lang="en-US" altLang="zh-CN" dirty="0"/>
           </a:p>
           <a:p>
             <a:r>
               <a:rPr lang="en-US" altLang="zh-CN" dirty="0"/>
               <a:t>Unambiguous steps to achieve from “untied” to “tied”</a:t>
             </a:r>
-            <a:endParaRPr lang="en-US" altLang="zh-CN" dirty="0"/>
           </a:p>
           <a:p>
             <a:r>
               <a:rPr lang="en-US" altLang="zh-CN" dirty="0"/>
               <a:t>Written in English,  Graph (UML) is optional. </a:t>
             </a:r>
-            <a:endParaRPr lang="en-US" altLang="zh-CN" dirty="0"/>
           </a:p>
           <a:p>
             <a:pPr lvl="1"/>
@@ -18509,7 +18288,6 @@
               <a:rPr lang="en-US" altLang="zh-CN" dirty="0"/>
               <a:t>2 pairs work together for a new spec</a:t>
             </a:r>
-            <a:endParaRPr lang="en-US" altLang="zh-CN" dirty="0"/>
           </a:p>
           <a:p>
             <a:pPr lvl="1"/>
@@ -18517,7 +18295,6 @@
               <a:rPr lang="en-US" altLang="zh-CN" dirty="0"/>
               <a:t>10 minutes to improve the spec </a:t>
             </a:r>
-            <a:endParaRPr lang="en-US" altLang="zh-CN" dirty="0"/>
           </a:p>
         </p:txBody>
       </p:sp>
@@ -19098,7 +18875,6 @@
               <a:rPr lang="en-US" altLang="zh-CN" dirty="0"/>
               <a:t>start from empty eyelets?</a:t>
             </a:r>
-            <a:endParaRPr lang="en-US" altLang="zh-CN" dirty="0"/>
           </a:p>
           <a:p>
             <a:r>
@@ -19118,7 +18894,7 @@
           <p:nvPr/>
         </p:nvPicPr>
         <p:blipFill>
-          <a:blip r:embed="rId1" cstate="print"/>
+          <a:blip r:embed="rId2" cstate="print"/>
           <a:srcRect/>
           <a:stretch>
             <a:fillRect/>
@@ -19192,7 +18968,7 @@
       <p:pic>
         <p:nvPicPr>
           <p:cNvPr id="4" name="Content Placeholder 3" descr="ace your laces how you tie your laces ... ">
-            <a:hlinkClick r:id="rId1" tooltip="&quot;ace your laces how you tie your laces ... &quot;"/>
+            <a:hlinkClick r:id="rId3" tooltip="&quot;ace your laces how you tie your laces ... &quot;"/>
           </p:cNvPr>
           <p:cNvPicPr>
             <a:picLocks noGrp="1"/>
@@ -19202,7 +18978,7 @@
           </p:nvPr>
         </p:nvPicPr>
         <p:blipFill>
-          <a:blip r:embed="rId2" cstate="print"/>
+          <a:blip r:embed="rId4" cstate="print"/>
           <a:srcRect/>
           <a:stretch>
             <a:fillRect/>
@@ -19278,7 +19054,7 @@
       <p:pic>
         <p:nvPicPr>
           <p:cNvPr id="4" name="Content Placeholder 3" descr="Send stuffs you have to udhayamoorthi ... ">
-            <a:hlinkClick r:id="rId1" tooltip="&quot;Send stuffs you have to udhayamoorthi ... &quot;"/>
+            <a:hlinkClick r:id="rId2" tooltip="&quot;Send stuffs you have to udhayamoorthi ... &quot;"/>
           </p:cNvPr>
           <p:cNvPicPr>
             <a:picLocks noGrp="1"/>
@@ -19288,7 +19064,7 @@
           </p:nvPr>
         </p:nvPicPr>
         <p:blipFill>
-          <a:blip r:embed="rId2" cstate="print"/>
+          <a:blip r:embed="rId3" cstate="print"/>
           <a:srcRect/>
           <a:stretch>
             <a:fillRect/>
@@ -19347,7 +19123,7 @@
           </p:nvPr>
         </p:nvPicPr>
         <p:blipFill>
-          <a:blip r:embed="rId1" cstate="print"/>
+          <a:blip r:embed="rId2" cstate="print"/>
           <a:srcRect/>
           <a:stretch>
             <a:fillRect/>
@@ -19430,7 +19206,7 @@
           </p:nvPr>
         </p:nvPicPr>
         <p:blipFill>
-          <a:blip r:embed="rId1" cstate="print"/>
+          <a:blip r:embed="rId2" cstate="print"/>
           <a:srcRect/>
           <a:stretch>
             <a:fillRect/>
@@ -19512,7 +19288,7 @@
           </p:nvPr>
         </p:nvPicPr>
         <p:blipFill>
-          <a:blip r:embed="rId1" cstate="print"/>
+          <a:blip r:embed="rId2" cstate="print"/>
           <a:srcRect/>
           <a:stretch>
             <a:fillRect/>
@@ -19602,7 +19378,6 @@
               <a:rPr lang="en-US" altLang="zh-CN" dirty="0"/>
               <a:t>What does “success” look like?</a:t>
             </a:r>
-            <a:endParaRPr lang="en-US" altLang="zh-CN" dirty="0"/>
           </a:p>
           <a:p>
             <a:pPr lvl="1"/>
@@ -19610,7 +19385,6 @@
               <a:rPr lang="en-US" altLang="zh-CN" dirty="0"/>
               <a:t>Can you use unambiguous words to describe it?</a:t>
             </a:r>
-            <a:endParaRPr lang="en-US" altLang="zh-CN" dirty="0"/>
           </a:p>
           <a:p>
             <a:pPr lvl="1"/>
@@ -19681,7 +19455,7 @@
           </p:nvPr>
         </p:nvPicPr>
         <p:blipFill>
-          <a:blip r:embed="rId1" cstate="print"/>
+          <a:blip r:embed="rId2" cstate="print"/>
           <a:srcRect/>
           <a:stretch>
             <a:fillRect/>
@@ -19773,14 +19547,12 @@
               <a:rPr lang="en-US" altLang="zh-CN" sz="2400" dirty="0"/>
               <a:t>Title</a:t>
             </a:r>
-            <a:endParaRPr lang="en-US" altLang="zh-CN" sz="2400" dirty="0"/>
           </a:p>
           <a:p>
             <a:r>
               <a:rPr lang="en-US" altLang="zh-CN" sz="2400" dirty="0"/>
               <a:t>Status</a:t>
             </a:r>
-            <a:endParaRPr lang="en-US" altLang="zh-CN" sz="2400" dirty="0"/>
           </a:p>
           <a:p>
             <a:pPr lvl="1"/>
@@ -19788,14 +19560,12 @@
               <a:rPr lang="en-US" altLang="zh-CN" sz="2000" dirty="0"/>
               <a:t>Incomplete / complete</a:t>
             </a:r>
-            <a:endParaRPr lang="en-US" altLang="zh-CN" sz="2000" dirty="0"/>
           </a:p>
           <a:p>
             <a:r>
               <a:rPr lang="en-US" altLang="zh-CN" sz="2400" dirty="0"/>
               <a:t>Contact person (1 person)</a:t>
             </a:r>
-            <a:endParaRPr lang="en-US" altLang="zh-CN" sz="2400" dirty="0"/>
           </a:p>
           <a:p>
             <a:pPr lvl="1"/>
@@ -19803,21 +19573,18 @@
               <a:rPr lang="en-US" altLang="zh-CN" sz="2000" dirty="0"/>
               <a:t>Responsibility and accountability,  still based on team input</a:t>
             </a:r>
-            <a:endParaRPr lang="en-US" altLang="zh-CN" sz="2000" dirty="0"/>
           </a:p>
           <a:p>
             <a:r>
               <a:rPr lang="en-US" altLang="zh-CN" sz="2400" dirty="0"/>
               <a:t>Overview</a:t>
             </a:r>
-            <a:endParaRPr lang="en-US" altLang="zh-CN" sz="2400" dirty="0"/>
           </a:p>
           <a:p>
             <a:r>
               <a:rPr lang="en-US" altLang="zh-CN" sz="2400" dirty="0"/>
               <a:t>Scenarios</a:t>
             </a:r>
-            <a:endParaRPr lang="en-US" altLang="zh-CN" sz="2400" dirty="0"/>
           </a:p>
           <a:p>
             <a:pPr lvl="1"/>
@@ -19825,7 +19592,6 @@
               <a:rPr lang="en-US" altLang="zh-CN" sz="2000" dirty="0"/>
               <a:t>How people benefit from the feature you describe</a:t>
             </a:r>
-            <a:endParaRPr lang="en-US" altLang="zh-CN" sz="2000" dirty="0"/>
           </a:p>
           <a:p>
             <a:pPr lvl="1"/>
@@ -19833,14 +19599,12 @@
               <a:rPr lang="en-US" altLang="zh-CN" sz="2000" dirty="0"/>
               <a:t>Go as detail as you can</a:t>
             </a:r>
-            <a:endParaRPr lang="en-US" altLang="zh-CN" sz="2000" dirty="0"/>
           </a:p>
           <a:p>
             <a:r>
               <a:rPr lang="en-US" altLang="zh-CN" sz="2400" dirty="0"/>
               <a:t>Non-goals</a:t>
             </a:r>
-            <a:endParaRPr lang="en-US" altLang="zh-CN" sz="2400" dirty="0"/>
           </a:p>
           <a:p>
             <a:r>
@@ -20640,7 +20404,6 @@
               <a:rPr lang="en-US" b="1" dirty="0"/>
               <a:t>Develop Overall Model</a:t>
             </a:r>
-            <a:endParaRPr lang="en-US" b="1" dirty="0"/>
           </a:p>
           <a:p>
             <a:pPr marL="0" indent="0">
@@ -20648,13 +20411,8 @@
             </a:pPr>
             <a:r>
               <a:rPr lang="en-US" b="0" dirty="0"/>
-              <a:t>The project starts with a high-level </a:t>
-            </a:r>
-            <a:r>
-              <a:rPr lang="en-US" b="0" dirty="0"/>
-              <a:t>walkthrough of the scope of the system and its context. </a:t>
-            </a:r>
-            <a:endParaRPr lang="en-US" b="0" dirty="0"/>
+              <a:t>The project starts with a high-level walkthrough of the scope of the system and its context. </a:t>
+            </a:r>
           </a:p>
           <a:p>
             <a:pPr marL="0" indent="0">
@@ -20674,7 +20432,6 @@
               <a:rPr lang="en-US" b="1" dirty="0"/>
               <a:t>Build Feature List</a:t>
             </a:r>
-            <a:endParaRPr lang="en-US" b="1" dirty="0"/>
           </a:p>
           <a:p>
             <a:pPr marL="0" indent="0">
@@ -20682,13 +20439,8 @@
             </a:pPr>
             <a:r>
               <a:rPr lang="en-US" b="0" dirty="0"/>
-              <a:t>identify a list of features. extract </a:t>
-            </a:r>
-            <a:r>
-              <a:rPr lang="en-US" b="0" dirty="0"/>
-              <a:t>business activities, the steps within each business activity form the categorized feature list. </a:t>
-            </a:r>
-            <a:endParaRPr lang="en-US" b="0" dirty="0"/>
+              <a:t>identify a list of features. extract business activities, the steps within each business activity form the categorized feature list. </a:t>
+            </a:r>
           </a:p>
           <a:p>
             <a:pPr marL="0" indent="0">
@@ -20702,7 +20454,6 @@
               <a:rPr lang="en-US" b="1" dirty="0"/>
               <a:t>&lt;action&gt; &lt;result&gt; &lt;object&gt;: </a:t>
             </a:r>
-            <a:endParaRPr lang="en-US" b="1" dirty="0"/>
           </a:p>
           <a:p>
             <a:pPr marL="0" indent="0">
@@ -20712,7 +20463,6 @@
               <a:rPr lang="en-US" b="0" dirty="0"/>
               <a:t>	Calculate the total of a sale  </a:t>
             </a:r>
-            <a:endParaRPr lang="en-US" b="0" dirty="0"/>
           </a:p>
           <a:p>
             <a:pPr marL="0" indent="0">
@@ -20722,7 +20472,6 @@
               <a:rPr lang="en-US" b="0" dirty="0"/>
               <a:t>               Validate the password of a user</a:t>
             </a:r>
-            <a:endParaRPr lang="en-US" b="0" dirty="0"/>
           </a:p>
           <a:p>
             <a:pPr marL="0" indent="0">
@@ -20740,7 +20489,6 @@
               <a:rPr lang="en-US" b="0" dirty="0"/>
               <a:t>hare comments to other users</a:t>
             </a:r>
-            <a:endParaRPr lang="en-US" b="0" dirty="0"/>
           </a:p>
           <a:p>
             <a:pPr marL="0" indent="0">
@@ -20764,7 +20512,6 @@
               <a:rPr lang="en-US" b="1" dirty="0"/>
               <a:t>lan By Feature</a:t>
             </a:r>
-            <a:endParaRPr lang="en-US" b="1" dirty="0"/>
           </a:p>
           <a:p>
             <a:pPr marL="0" indent="0">
@@ -20774,7 +20521,6 @@
               <a:rPr lang="en-US" b="0" dirty="0"/>
               <a:t>Produce the development plan – who is going to do it, when?</a:t>
             </a:r>
-            <a:endParaRPr lang="en-US" b="0" dirty="0"/>
           </a:p>
         </p:txBody>
       </p:sp>
@@ -20822,7 +20568,6 @@
               <a:rPr lang="en-US" dirty="0"/>
               <a:t>Design &amp; Build</a:t>
             </a:r>
-            <a:endParaRPr lang="en-US" dirty="0"/>
           </a:p>
         </p:txBody>
       </p:sp>
@@ -20854,7 +20599,6 @@
               <a:rPr lang="en-US" b="1" dirty="0"/>
               <a:t>Design By Feature</a:t>
             </a:r>
-            <a:endParaRPr lang="en-US" b="1" dirty="0"/>
           </a:p>
           <a:p>
             <a:pPr marL="457200" indent="-457200"/>
@@ -20874,7 +20618,6 @@
               <a:rPr lang="en-US" b="0" dirty="0"/>
               <a:t>.</a:t>
             </a:r>
-            <a:endParaRPr lang="en-US" b="0" dirty="0"/>
           </a:p>
           <a:p>
             <a:endParaRPr lang="en-US" b="1" dirty="0"/>
@@ -20891,7 +20634,6 @@
               <a:rPr lang="en-US" b="1" dirty="0"/>
               <a:t>Build By Feature</a:t>
             </a:r>
-            <a:endParaRPr lang="en-US" b="1" dirty="0"/>
           </a:p>
           <a:p>
             <a:r>
@@ -20954,7 +20696,6 @@
               <a:rPr lang="en-US" dirty="0"/>
               <a:t>FDD – Best Practices</a:t>
             </a:r>
-            <a:endParaRPr lang="en-US" dirty="0"/>
           </a:p>
         </p:txBody>
       </p:sp>
@@ -20992,7 +20733,6 @@
               <a:rPr lang="en-US" dirty="0"/>
               <a:t>Domain Object Modeling. </a:t>
             </a:r>
-            <a:endParaRPr lang="en-US" dirty="0"/>
           </a:p>
           <a:p>
             <a:pPr marL="400050" lvl="1" indent="0">
@@ -21026,7 +20766,6 @@
               <a:rPr lang="en-US" dirty="0"/>
               <a:t> </a:t>
             </a:r>
-            <a:endParaRPr lang="en-US" dirty="0"/>
           </a:p>
           <a:p>
             <a:pPr>
@@ -21050,7 +20789,6 @@
               <a:rPr lang="en-US" dirty="0"/>
               <a:t>Developing by Feature. </a:t>
             </a:r>
-            <a:endParaRPr lang="en-US" dirty="0"/>
           </a:p>
           <a:p>
             <a:pPr marL="400050" lvl="1" indent="0">
@@ -21091,7 +20829,6 @@
               <a:rPr lang="en-US" dirty="0"/>
               <a:t>Individual Class (Code) Ownership. </a:t>
             </a:r>
-            <a:endParaRPr lang="en-US" dirty="0"/>
           </a:p>
           <a:p>
             <a:pPr marL="400050" lvl="1" indent="0">
@@ -21137,7 +20874,6 @@
               <a:rPr lang="en-US" dirty="0"/>
               <a:t>Feature Teams. </a:t>
             </a:r>
-            <a:endParaRPr lang="en-US" dirty="0"/>
           </a:p>
           <a:p>
             <a:pPr marL="400050" lvl="1" indent="0">
@@ -21198,7 +20934,6 @@
               <a:rPr lang="en-US" dirty="0"/>
               <a:t>FDD – Best Practices</a:t>
             </a:r>
-            <a:endParaRPr lang="en-US" dirty="0"/>
           </a:p>
         </p:txBody>
       </p:sp>
@@ -21227,7 +20962,6 @@
               <a:rPr lang="en-US" dirty="0"/>
               <a:t>Inspections. </a:t>
             </a:r>
-            <a:endParaRPr lang="en-US" dirty="0"/>
           </a:p>
           <a:p>
             <a:pPr marL="400050" lvl="1" indent="0">
@@ -21249,7 +20983,6 @@
               <a:rPr lang="en-US" dirty="0"/>
               <a:t>Regular Builds. </a:t>
             </a:r>
-            <a:endParaRPr lang="en-US" dirty="0"/>
           </a:p>
           <a:p>
             <a:pPr marL="400050" lvl="1" indent="0">
@@ -21263,7 +20996,6 @@
               <a:rPr lang="en-US" dirty="0"/>
               <a:t>.</a:t>
             </a:r>
-            <a:endParaRPr lang="en-US" dirty="0"/>
           </a:p>
           <a:p>
             <a:r>
@@ -21274,7 +21006,6 @@
               <a:rPr lang="en-US" dirty="0"/>
               <a:t>Visibility of progress and results. </a:t>
             </a:r>
-            <a:endParaRPr lang="en-US" dirty="0"/>
           </a:p>
           <a:p>
             <a:pPr marL="400050" lvl="1" indent="0">
@@ -21363,7 +21094,6 @@
               <a:rPr lang="en-US" dirty="0"/>
               <a:t>Story of coke vs. Pepsi</a:t>
             </a:r>
-            <a:endParaRPr lang="en-US" dirty="0"/>
           </a:p>
           <a:p>
             <a:pPr lvl="1"/>
@@ -21371,14 +21101,12 @@
               <a:rPr lang="en-US" dirty="0"/>
               <a:t>First Taste vs. long term taste</a:t>
             </a:r>
-            <a:endParaRPr lang="en-US" dirty="0"/>
           </a:p>
           <a:p>
             <a:r>
               <a:rPr lang="en-US" dirty="0"/>
               <a:t>Scenario means</a:t>
             </a:r>
-            <a:endParaRPr lang="en-US" dirty="0"/>
           </a:p>
           <a:p>
             <a:pPr lvl="1"/>
@@ -21386,7 +21114,6 @@
               <a:rPr lang="en-US" dirty="0"/>
               <a:t>Experience in first 3 minutes</a:t>
             </a:r>
-            <a:endParaRPr lang="en-US" dirty="0"/>
           </a:p>
           <a:p>
             <a:pPr lvl="1"/>
@@ -21394,7 +21121,6 @@
               <a:rPr lang="en-US" dirty="0"/>
               <a:t>Long term experience</a:t>
             </a:r>
-            <a:endParaRPr lang="en-US" dirty="0"/>
           </a:p>
         </p:txBody>
       </p:sp>
@@ -21463,7 +21189,7 @@
           <a:p>
             <a:r>
               <a:rPr lang="en-US" dirty="0">
-                <a:hlinkClick r:id="rId1"/>
+                <a:hlinkClick r:id="rId2"/>
               </a:rPr>
               <a:t>http://www.cnblogs.com/xinz/p/3855296.html</a:t>
             </a:r>
@@ -21471,7 +21197,6 @@
               <a:rPr lang="en-US" dirty="0"/>
               <a:t> </a:t>
             </a:r>
-            <a:endParaRPr lang="en-US" dirty="0"/>
           </a:p>
         </p:txBody>
       </p:sp>
@@ -21519,7 +21244,6 @@
               <a:rPr lang="en-US" dirty="0"/>
               <a:t>Example 4</a:t>
             </a:r>
-            <a:endParaRPr lang="en-US" dirty="0"/>
           </a:p>
         </p:txBody>
       </p:sp>
@@ -21542,7 +21266,6 @@
               <a:rPr lang="en-US" dirty="0"/>
               <a:t>“Minority Report”</a:t>
             </a:r>
-            <a:endParaRPr lang="en-US" dirty="0"/>
           </a:p>
         </p:txBody>
       </p:sp>
@@ -21618,7 +21341,7 @@
           <p:nvPr/>
         </p:nvPicPr>
         <p:blipFill>
-          <a:blip r:embed="rId1">
+          <a:blip r:embed="rId2">
             <a:extLst>
               <a:ext uri="{28A0092B-C50C-407E-A947-70E740481C1C}">
                 <a14:useLocalDpi xmlns:a14="http://schemas.microsoft.com/office/drawing/2010/main" val="0"/>
@@ -21719,7 +21442,6 @@
               <a:rPr lang="en-US" dirty="0"/>
               <a:t>Working like that for 8 hours?</a:t>
             </a:r>
-            <a:endParaRPr lang="en-US" dirty="0"/>
           </a:p>
         </p:txBody>
       </p:sp>
@@ -21742,14 +21464,12 @@
               <a:rPr lang="en-US" dirty="0"/>
               <a:t>It’s cool on demo,  but your arms will become very tired when using it for a long time. </a:t>
             </a:r>
-            <a:endParaRPr lang="en-US" dirty="0"/>
           </a:p>
           <a:p>
             <a:r>
               <a:rPr lang="en-US" dirty="0"/>
               <a:t>According to Andy Van Dam, the movie crew hung Tom Cruise’s arms after he become so tired after a while</a:t>
             </a:r>
-            <a:endParaRPr lang="en-US" dirty="0"/>
           </a:p>
           <a:p>
             <a:pPr marL="68580" indent="0">
@@ -21803,7 +21523,6 @@
               <a:rPr lang="en-US" dirty="0"/>
               <a:t>Example 5</a:t>
             </a:r>
-            <a:endParaRPr lang="en-US" dirty="0"/>
           </a:p>
         </p:txBody>
       </p:sp>
@@ -21828,7 +21547,6 @@
               <a:rPr lang="en-US" dirty="0"/>
               <a:t>A foreign student needs to set up online banking in China</a:t>
             </a:r>
-            <a:endParaRPr lang="en-US" dirty="0"/>
           </a:p>
           <a:p>
             <a:pPr lvl="1"/>
@@ -21840,7 +21558,6 @@
               <a:rPr lang="en-US" b="1" dirty="0"/>
               <a:t>English</a:t>
             </a:r>
-            <a:endParaRPr lang="en-US" b="1" dirty="0"/>
           </a:p>
           <a:p>
             <a:pPr lvl="1"/>
@@ -21848,7 +21565,6 @@
               <a:rPr lang="en-US" dirty="0"/>
               <a:t>Finish the require steps</a:t>
             </a:r>
-            <a:endParaRPr lang="en-US" dirty="0"/>
           </a:p>
           <a:p>
             <a:pPr lvl="1"/>
@@ -21856,7 +21572,6 @@
               <a:rPr lang="en-US" dirty="0"/>
               <a:t>Bank sends a password to user’s cell phone via SMS</a:t>
             </a:r>
-            <a:endParaRPr lang="en-US" dirty="0"/>
           </a:p>
           <a:p>
             <a:pPr lvl="1"/>
@@ -21864,7 +21579,6 @@
               <a:rPr lang="en-US" dirty="0"/>
               <a:t>Problem</a:t>
             </a:r>
-            <a:endParaRPr lang="en-US" dirty="0"/>
           </a:p>
           <a:p>
             <a:pPr lvl="2"/>
@@ -21876,7 +21590,6 @@
               <a:rPr lang="en-US" b="1" dirty="0"/>
               <a:t>English</a:t>
             </a:r>
-            <a:endParaRPr lang="en-US" b="1" dirty="0"/>
           </a:p>
           <a:p>
             <a:pPr lvl="2"/>
@@ -22095,6 +21808,8 @@
       </a:bgFillStyleLst>
     </a:fmtScheme>
   </a:themeElements>
+  <a:objectDefaults/>
+  <a:extraClrSchemeLst/>
   <a:extLst>
     <a:ext uri="{05A4C25C-085E-4340-85A3-A5531E510DB2}">
       <thm15:themeFamily xmlns:thm15="http://schemas.microsoft.com/office/thememl/2012/main" name="Office Theme" id="{62F939B6-93AF-4DB8-9C6B-D6C7DFDC589F}" vid="{4A3C46E8-61CC-4603-A589-7422A47A8E4A}"/>
@@ -22383,6 +22098,8 @@
       </a:bgFillStyleLst>
     </a:fmtScheme>
   </a:themeElements>
+  <a:objectDefaults/>
+  <a:extraClrSchemeLst/>
   <a:extLst>
     <a:ext uri="{05A4C25C-085E-4340-85A3-A5531E510DB2}">
       <thm15:themeFamily xmlns:thm15="http://schemas.microsoft.com/office/thememl/2012/main" name="Office Theme" id="{62F939B6-93AF-4DB8-9C6B-D6C7DFDC589F}" vid="{4A3C46E8-61CC-4603-A589-7422A47A8E4A}"/>
@@ -22392,12 +22109,6 @@
 </file>
 
 <file path=customXml/item1.xml><?xml version="1.0" encoding="utf-8"?>
-<p:properties xmlns:p="http://schemas.microsoft.com/office/2006/metadata/properties" xmlns:xsi="http://www.w3.org/2001/XMLSchema-instance" xmlns:pc="http://schemas.microsoft.com/office/infopath/2007/PartnerControls">
-  <documentManagement/>
-</p:properties>
-</file>
-
-<file path=customXml/item2.xml><?xml version="1.0" encoding="utf-8"?>
 <?mso-contentType ?>
 <FormTemplates xmlns="http://schemas.microsoft.com/sharepoint/v3/contenttype/forms">
   <Display>DocumentLibraryForm</Display>
@@ -22406,7 +22117,7 @@
 </FormTemplates>
 </file>
 
-<file path=customXml/item3.xml><?xml version="1.0" encoding="utf-8"?>
+<file path=customXml/item2.xml><?xml version="1.0" encoding="utf-8"?>
 <ct:contentTypeSchema xmlns:ct="http://schemas.microsoft.com/office/2006/metadata/contentType" xmlns:ma="http://schemas.microsoft.com/office/2006/metadata/properties/metaAttributes" ct:_="" ma:_="" ma:contentTypeName="Document" ma:contentTypeID="0x0101006371182FA640024E8A2815D490E1EF25" ma:contentTypeVersion="0" ma:contentTypeDescription="Create a new document." ma:contentTypeScope="" ma:versionID="3591aab47f172a2900f307f59d422227">
   <xsd:schema xmlns:xsd="http://www.w3.org/2001/XMLSchema" xmlns:xs="http://www.w3.org/2001/XMLSchema" xmlns:p="http://schemas.microsoft.com/office/2006/metadata/properties" targetNamespace="http://schemas.microsoft.com/office/2006/metadata/properties" ma:root="true" ma:fieldsID="1f28ea01430cdfb20a10736313f817e3">
     <xsd:element name="properties">
@@ -22520,20 +22231,26 @@
 </ct:contentTypeSchema>
 </file>
 
+<file path=customXml/item3.xml><?xml version="1.0" encoding="utf-8"?>
+<p:properties xmlns:p="http://schemas.microsoft.com/office/2006/metadata/properties" xmlns:xsi="http://www.w3.org/2001/XMLSchema-instance" xmlns:pc="http://schemas.microsoft.com/office/infopath/2007/PartnerControls">
+  <documentManagement/>
+</p:properties>
+</file>
+
 <file path=customXml/itemProps1.xml><?xml version="1.0" encoding="utf-8"?>
-<ds:datastoreItem xmlns:ds="http://schemas.openxmlformats.org/officeDocument/2006/customXml" ds:itemID="{4F629853-C7D0-46CE-AC9C-EE05D5845B6F}">
+<ds:datastoreItem xmlns:ds="http://schemas.openxmlformats.org/officeDocument/2006/customXml" ds:itemID="{D22C73DB-441F-4C47-B04F-FB61D580DDAC}">
   <ds:schemaRefs/>
 </ds:datastoreItem>
 </file>
 
 <file path=customXml/itemProps2.xml><?xml version="1.0" encoding="utf-8"?>
-<ds:datastoreItem xmlns:ds="http://schemas.openxmlformats.org/officeDocument/2006/customXml" ds:itemID="{D22C73DB-441F-4C47-B04F-FB61D580DDAC}">
+<ds:datastoreItem xmlns:ds="http://schemas.openxmlformats.org/officeDocument/2006/customXml" ds:itemID="{13FD6AA0-81A8-40DC-9351-62F8A96B815C}">
   <ds:schemaRefs/>
 </ds:datastoreItem>
 </file>
 
 <file path=customXml/itemProps3.xml><?xml version="1.0" encoding="utf-8"?>
-<ds:datastoreItem xmlns:ds="http://schemas.openxmlformats.org/officeDocument/2006/customXml" ds:itemID="{13FD6AA0-81A8-40DC-9351-62F8A96B815C}">
+<ds:datastoreItem xmlns:ds="http://schemas.openxmlformats.org/officeDocument/2006/customXml" ds:itemID="{4F629853-C7D0-46CE-AC9C-EE05D5845B6F}">
   <ds:schemaRefs/>
 </ds:datastoreItem>
 </file>
</xml_diff>